<commit_message>
Polish deep dive deck side panels
</commit_message>
<xml_diff>
--- a/docs/zh/10-Claude Code 源码深度解读.pptx
+++ b/docs/zh/10-Claude Code 源码深度解读.pptx
@@ -5586,7 +5586,7 @@
                 </a:solidFill>
                 <a:latin typeface="Arial"/>
               </a:rPr>
-              <a:t>源码理解支撑</a:t>
+              <a:t>实践含义</a:t>
             </a:r>
           </a:p>
         </p:txBody>
@@ -5599,8 +5599,8 @@
         </p:nvSpPr>
         <p:spPr>
           <a:xfrm>
-            <a:off x="7223760" y="2706624"/>
-            <a:ext cx="4242816" cy="3218688"/>
+            <a:off x="7296912" y="2706624"/>
+            <a:ext cx="4078224" cy="3200400"/>
           </a:xfrm>
           <a:prstGeom prst="rect">
             <a:avLst/>
@@ -5619,7 +5619,7 @@
               </a:spcAft>
             </a:pPr>
             <a:r>
-              <a:rPr sz="1250" b="0">
+              <a:rPr sz="1700" b="0">
                 <a:solidFill>
                   <a:srgbClr val="DCE4F2"/>
                 </a:solidFill>
@@ -6143,7 +6143,7 @@
                 </a:solidFill>
                 <a:latin typeface="Arial"/>
               </a:rPr>
-              <a:t>源码理解支撑</a:t>
+              <a:t>实践含义</a:t>
             </a:r>
           </a:p>
         </p:txBody>
@@ -6156,8 +6156,8 @@
         </p:nvSpPr>
         <p:spPr>
           <a:xfrm>
-            <a:off x="7223760" y="2706624"/>
-            <a:ext cx="4242816" cy="3218688"/>
+            <a:off x="7296912" y="2706624"/>
+            <a:ext cx="4078224" cy="3200400"/>
           </a:xfrm>
           <a:prstGeom prst="rect">
             <a:avLst/>
@@ -6176,7 +6176,7 @@
               </a:spcAft>
             </a:pPr>
             <a:r>
-              <a:rPr sz="1250" b="0">
+              <a:rPr sz="1700" b="0">
                 <a:solidFill>
                   <a:srgbClr val="DCE4F2"/>
                 </a:solidFill>
@@ -6700,7 +6700,7 @@
                 </a:solidFill>
                 <a:latin typeface="Arial"/>
               </a:rPr>
-              <a:t>源码理解支撑</a:t>
+              <a:t>实践含义</a:t>
             </a:r>
           </a:p>
         </p:txBody>
@@ -6713,8 +6713,8 @@
         </p:nvSpPr>
         <p:spPr>
           <a:xfrm>
-            <a:off x="7223760" y="2706624"/>
-            <a:ext cx="4242816" cy="3218688"/>
+            <a:off x="7296912" y="2706624"/>
+            <a:ext cx="4078224" cy="3200400"/>
           </a:xfrm>
           <a:prstGeom prst="rect">
             <a:avLst/>
@@ -6733,7 +6733,7 @@
               </a:spcAft>
             </a:pPr>
             <a:r>
-              <a:rPr sz="1250" b="0">
+              <a:rPr sz="1700" b="0">
                 <a:solidFill>
                   <a:srgbClr val="DCE4F2"/>
                 </a:solidFill>
@@ -7257,7 +7257,7 @@
                 </a:solidFill>
                 <a:latin typeface="Arial"/>
               </a:rPr>
-              <a:t>源码理解支撑</a:t>
+              <a:t>实践含义</a:t>
             </a:r>
           </a:p>
         </p:txBody>
@@ -7270,8 +7270,8 @@
         </p:nvSpPr>
         <p:spPr>
           <a:xfrm>
-            <a:off x="7223760" y="2706624"/>
-            <a:ext cx="4242816" cy="3218688"/>
+            <a:off x="7296912" y="2706624"/>
+            <a:ext cx="4078224" cy="3200400"/>
           </a:xfrm>
           <a:prstGeom prst="rect">
             <a:avLst/>
@@ -7290,7 +7290,7 @@
               </a:spcAft>
             </a:pPr>
             <a:r>
-              <a:rPr sz="1250" b="0">
+              <a:rPr sz="1700" b="0">
                 <a:solidFill>
                   <a:srgbClr val="DCE4F2"/>
                 </a:solidFill>
@@ -7926,7 +7926,7 @@
                 </a:solidFill>
                 <a:latin typeface="Arial"/>
               </a:rPr>
-              <a:t>这段代码说明了什么</a:t>
+              <a:t>这段代码说明什么</a:t>
             </a:r>
           </a:p>
         </p:txBody>
@@ -8483,7 +8483,7 @@
                 </a:solidFill>
                 <a:latin typeface="Arial"/>
               </a:rPr>
-              <a:t>源码理解支撑</a:t>
+              <a:t>实践含义</a:t>
             </a:r>
           </a:p>
         </p:txBody>
@@ -8496,8 +8496,8 @@
         </p:nvSpPr>
         <p:spPr>
           <a:xfrm>
-            <a:off x="7223760" y="2706624"/>
-            <a:ext cx="4242816" cy="3218688"/>
+            <a:off x="7296912" y="2706624"/>
+            <a:ext cx="4078224" cy="3200400"/>
           </a:xfrm>
           <a:prstGeom prst="rect">
             <a:avLst/>
@@ -8516,7 +8516,7 @@
               </a:spcAft>
             </a:pPr>
             <a:r>
-              <a:rPr sz="1250" b="0">
+              <a:rPr sz="1700" b="0">
                 <a:solidFill>
                   <a:srgbClr val="DCE4F2"/>
                 </a:solidFill>
@@ -9040,7 +9040,7 @@
                 </a:solidFill>
                 <a:latin typeface="Arial"/>
               </a:rPr>
-              <a:t>源码理解支撑</a:t>
+              <a:t>实践含义</a:t>
             </a:r>
           </a:p>
         </p:txBody>
@@ -9053,8 +9053,8 @@
         </p:nvSpPr>
         <p:spPr>
           <a:xfrm>
-            <a:off x="7223760" y="2706624"/>
-            <a:ext cx="4242816" cy="3218688"/>
+            <a:off x="7296912" y="2706624"/>
+            <a:ext cx="4078224" cy="3200400"/>
           </a:xfrm>
           <a:prstGeom prst="rect">
             <a:avLst/>
@@ -9073,7 +9073,7 @@
               </a:spcAft>
             </a:pPr>
             <a:r>
-              <a:rPr sz="1250" b="0">
+              <a:rPr sz="1700" b="0">
                 <a:solidFill>
                   <a:srgbClr val="DCE4F2"/>
                 </a:solidFill>
@@ -11303,7 +11303,7 @@
                 </a:solidFill>
                 <a:latin typeface="Arial"/>
               </a:rPr>
-              <a:t>源码理解支撑</a:t>
+              <a:t>实践含义</a:t>
             </a:r>
           </a:p>
         </p:txBody>
@@ -11316,8 +11316,8 @@
         </p:nvSpPr>
         <p:spPr>
           <a:xfrm>
-            <a:off x="7223760" y="2706624"/>
-            <a:ext cx="4242816" cy="3218688"/>
+            <a:off x="7296912" y="2706624"/>
+            <a:ext cx="4078224" cy="3200400"/>
           </a:xfrm>
           <a:prstGeom prst="rect">
             <a:avLst/>
@@ -11336,7 +11336,7 @@
               </a:spcAft>
             </a:pPr>
             <a:r>
-              <a:rPr sz="1250" b="0">
+              <a:rPr sz="1700" b="0">
                 <a:solidFill>
                   <a:srgbClr val="DCE4F2"/>
                 </a:solidFill>
@@ -11876,7 +11876,7 @@
                 </a:solidFill>
                 <a:latin typeface="Arial"/>
               </a:rPr>
-              <a:t>源码理解支撑</a:t>
+              <a:t>实践含义</a:t>
             </a:r>
           </a:p>
         </p:txBody>
@@ -11889,8 +11889,8 @@
         </p:nvSpPr>
         <p:spPr>
           <a:xfrm>
-            <a:off x="7223760" y="2706624"/>
-            <a:ext cx="4242816" cy="3218688"/>
+            <a:off x="7296912" y="2706624"/>
+            <a:ext cx="4078224" cy="3200400"/>
           </a:xfrm>
           <a:prstGeom prst="rect">
             <a:avLst/>
@@ -11909,7 +11909,7 @@
               </a:spcAft>
             </a:pPr>
             <a:r>
-              <a:rPr sz="1250" b="0">
+              <a:rPr sz="1700" b="0">
                 <a:solidFill>
                   <a:srgbClr val="DCE4F2"/>
                 </a:solidFill>
@@ -12433,7 +12433,7 @@
                 </a:solidFill>
                 <a:latin typeface="Arial"/>
               </a:rPr>
-              <a:t>源码理解支撑</a:t>
+              <a:t>实践含义</a:t>
             </a:r>
           </a:p>
         </p:txBody>
@@ -12446,8 +12446,8 @@
         </p:nvSpPr>
         <p:spPr>
           <a:xfrm>
-            <a:off x="7223760" y="2706624"/>
-            <a:ext cx="4242816" cy="3218688"/>
+            <a:off x="7296912" y="2706624"/>
+            <a:ext cx="4078224" cy="3200400"/>
           </a:xfrm>
           <a:prstGeom prst="rect">
             <a:avLst/>
@@ -12466,7 +12466,7 @@
               </a:spcAft>
             </a:pPr>
             <a:r>
-              <a:rPr sz="1250" b="0">
+              <a:rPr sz="1700" b="0">
                 <a:solidFill>
                   <a:srgbClr val="DCE4F2"/>
                 </a:solidFill>
@@ -12990,7 +12990,7 @@
                 </a:solidFill>
                 <a:latin typeface="Arial"/>
               </a:rPr>
-              <a:t>源码理解支撑</a:t>
+              <a:t>实践含义</a:t>
             </a:r>
           </a:p>
         </p:txBody>
@@ -13003,8 +13003,8 @@
         </p:nvSpPr>
         <p:spPr>
           <a:xfrm>
-            <a:off x="7223760" y="2706624"/>
-            <a:ext cx="4242816" cy="3218688"/>
+            <a:off x="7296912" y="2706624"/>
+            <a:ext cx="4078224" cy="3200400"/>
           </a:xfrm>
           <a:prstGeom prst="rect">
             <a:avLst/>
@@ -13023,7 +13023,7 @@
               </a:spcAft>
             </a:pPr>
             <a:r>
-              <a:rPr sz="1250" b="0">
+              <a:rPr sz="1700" b="0">
                 <a:solidFill>
                   <a:srgbClr val="DCE4F2"/>
                 </a:solidFill>
@@ -13547,7 +13547,7 @@
                 </a:solidFill>
                 <a:latin typeface="Arial"/>
               </a:rPr>
-              <a:t>源码理解支撑</a:t>
+              <a:t>实践含义</a:t>
             </a:r>
           </a:p>
         </p:txBody>
@@ -13560,8 +13560,8 @@
         </p:nvSpPr>
         <p:spPr>
           <a:xfrm>
-            <a:off x="7223760" y="2706624"/>
-            <a:ext cx="4242816" cy="3218688"/>
+            <a:off x="7296912" y="2706624"/>
+            <a:ext cx="4078224" cy="3200400"/>
           </a:xfrm>
           <a:prstGeom prst="rect">
             <a:avLst/>
@@ -13580,7 +13580,7 @@
               </a:spcAft>
             </a:pPr>
             <a:r>
-              <a:rPr sz="1250" b="0">
+              <a:rPr sz="1700" b="0">
                 <a:solidFill>
                   <a:srgbClr val="DCE4F2"/>
                 </a:solidFill>
@@ -14104,7 +14104,7 @@
                 </a:solidFill>
                 <a:latin typeface="Arial"/>
               </a:rPr>
-              <a:t>源码理解支撑</a:t>
+              <a:t>实践含义</a:t>
             </a:r>
           </a:p>
         </p:txBody>
@@ -14117,8 +14117,8 @@
         </p:nvSpPr>
         <p:spPr>
           <a:xfrm>
-            <a:off x="7223760" y="2706624"/>
-            <a:ext cx="4242816" cy="3218688"/>
+            <a:off x="7296912" y="2706624"/>
+            <a:ext cx="4078224" cy="3200400"/>
           </a:xfrm>
           <a:prstGeom prst="rect">
             <a:avLst/>
@@ -14137,7 +14137,7 @@
               </a:spcAft>
             </a:pPr>
             <a:r>
-              <a:rPr sz="1250" b="0">
+              <a:rPr sz="1700" b="0">
                 <a:solidFill>
                   <a:srgbClr val="DCE4F2"/>
                 </a:solidFill>
@@ -15160,7 +15160,7 @@
                 </a:solidFill>
                 <a:latin typeface="Arial"/>
               </a:rPr>
-              <a:t>这段代码说明了什么</a:t>
+              <a:t>这段代码说明什么</a:t>
             </a:r>
           </a:p>
         </p:txBody>
@@ -15827,7 +15827,7 @@
                 </a:solidFill>
                 <a:latin typeface="Arial"/>
               </a:rPr>
-              <a:t>这段代码说明了什么</a:t>
+              <a:t>这段代码说明什么</a:t>
             </a:r>
           </a:p>
         </p:txBody>
@@ -16495,7 +16495,7 @@
                 </a:solidFill>
                 <a:latin typeface="Arial"/>
               </a:rPr>
-              <a:t>这段代码说明了什么</a:t>
+              <a:t>这段代码说明什么</a:t>
             </a:r>
           </a:p>
         </p:txBody>
@@ -17164,7 +17164,7 @@
                 </a:solidFill>
                 <a:latin typeface="Arial"/>
               </a:rPr>
-              <a:t>这段代码说明了什么</a:t>
+              <a:t>这段代码说明什么</a:t>
             </a:r>
           </a:p>
         </p:txBody>
@@ -17721,7 +17721,7 @@
                 </a:solidFill>
                 <a:latin typeface="Arial"/>
               </a:rPr>
-              <a:t>源码理解支撑</a:t>
+              <a:t>实践含义</a:t>
             </a:r>
           </a:p>
         </p:txBody>
@@ -17734,8 +17734,8 @@
         </p:nvSpPr>
         <p:spPr>
           <a:xfrm>
-            <a:off x="7223760" y="2706624"/>
-            <a:ext cx="4242816" cy="3218688"/>
+            <a:off x="7296912" y="2706624"/>
+            <a:ext cx="4078224" cy="3200400"/>
           </a:xfrm>
           <a:prstGeom prst="rect">
             <a:avLst/>
@@ -17754,7 +17754,7 @@
               </a:spcAft>
             </a:pPr>
             <a:r>
-              <a:rPr sz="1250" b="0">
+              <a:rPr sz="1700" b="0">
                 <a:solidFill>
                   <a:srgbClr val="DCE4F2"/>
                 </a:solidFill>
@@ -18278,7 +18278,7 @@
                 </a:solidFill>
                 <a:latin typeface="Arial"/>
               </a:rPr>
-              <a:t>源码理解支撑</a:t>
+              <a:t>实践含义</a:t>
             </a:r>
           </a:p>
         </p:txBody>
@@ -18291,8 +18291,8 @@
         </p:nvSpPr>
         <p:spPr>
           <a:xfrm>
-            <a:off x="7223760" y="2706624"/>
-            <a:ext cx="4242816" cy="3218688"/>
+            <a:off x="7296912" y="2706624"/>
+            <a:ext cx="4078224" cy="3200400"/>
           </a:xfrm>
           <a:prstGeom prst="rect">
             <a:avLst/>
@@ -18311,7 +18311,7 @@
               </a:spcAft>
             </a:pPr>
             <a:r>
-              <a:rPr sz="1250" b="0">
+              <a:rPr sz="1700" b="0">
                 <a:solidFill>
                   <a:srgbClr val="DCE4F2"/>
                 </a:solidFill>
@@ -18835,7 +18835,7 @@
                 </a:solidFill>
                 <a:latin typeface="Arial"/>
               </a:rPr>
-              <a:t>源码理解支撑</a:t>
+              <a:t>实践含义</a:t>
             </a:r>
           </a:p>
         </p:txBody>
@@ -18848,8 +18848,8 @@
         </p:nvSpPr>
         <p:spPr>
           <a:xfrm>
-            <a:off x="7223760" y="2706624"/>
-            <a:ext cx="4242816" cy="3218688"/>
+            <a:off x="7296912" y="2706624"/>
+            <a:ext cx="4078224" cy="3200400"/>
           </a:xfrm>
           <a:prstGeom prst="rect">
             <a:avLst/>
@@ -18868,7 +18868,7 @@
               </a:spcAft>
             </a:pPr>
             <a:r>
-              <a:rPr sz="1250" b="0">
+              <a:rPr sz="1700" b="0">
                 <a:solidFill>
                   <a:srgbClr val="DCE4F2"/>
                 </a:solidFill>
@@ -19500,7 +19500,7 @@
                 </a:solidFill>
                 <a:latin typeface="Arial"/>
               </a:rPr>
-              <a:t>这段代码说明了什么</a:t>
+              <a:t>这段代码说明什么</a:t>
             </a:r>
           </a:p>
         </p:txBody>
@@ -20166,7 +20166,7 @@
                 </a:solidFill>
                 <a:latin typeface="Arial"/>
               </a:rPr>
-              <a:t>这段代码说明了什么</a:t>
+              <a:t>这段代码说明什么</a:t>
             </a:r>
           </a:p>
         </p:txBody>
@@ -20723,7 +20723,7 @@
                 </a:solidFill>
                 <a:latin typeface="Arial"/>
               </a:rPr>
-              <a:t>源码理解支撑</a:t>
+              <a:t>实践含义</a:t>
             </a:r>
           </a:p>
         </p:txBody>
@@ -20736,8 +20736,8 @@
         </p:nvSpPr>
         <p:spPr>
           <a:xfrm>
-            <a:off x="7223760" y="2706624"/>
-            <a:ext cx="4242816" cy="3218688"/>
+            <a:off x="7296912" y="2706624"/>
+            <a:ext cx="4078224" cy="3200400"/>
           </a:xfrm>
           <a:prstGeom prst="rect">
             <a:avLst/>
@@ -20756,7 +20756,7 @@
               </a:spcAft>
             </a:pPr>
             <a:r>
-              <a:rPr sz="1250" b="0">
+              <a:rPr sz="1700" b="0">
                 <a:solidFill>
                   <a:srgbClr val="DCE4F2"/>
                 </a:solidFill>
@@ -21280,7 +21280,7 @@
                 </a:solidFill>
                 <a:latin typeface="Arial"/>
               </a:rPr>
-              <a:t>源码理解支撑</a:t>
+              <a:t>实践含义</a:t>
             </a:r>
           </a:p>
         </p:txBody>
@@ -21293,8 +21293,8 @@
         </p:nvSpPr>
         <p:spPr>
           <a:xfrm>
-            <a:off x="7223760" y="2706624"/>
-            <a:ext cx="4242816" cy="3218688"/>
+            <a:off x="7296912" y="2706624"/>
+            <a:ext cx="4078224" cy="3200400"/>
           </a:xfrm>
           <a:prstGeom prst="rect">
             <a:avLst/>
@@ -21313,7 +21313,7 @@
               </a:spcAft>
             </a:pPr>
             <a:r>
-              <a:rPr sz="1250" b="0">
+              <a:rPr sz="1700" b="0">
                 <a:solidFill>
                   <a:srgbClr val="DCE4F2"/>
                 </a:solidFill>
@@ -21837,7 +21837,7 @@
                 </a:solidFill>
                 <a:latin typeface="Arial"/>
               </a:rPr>
-              <a:t>源码理解支撑</a:t>
+              <a:t>实践含义</a:t>
             </a:r>
           </a:p>
         </p:txBody>
@@ -21850,8 +21850,8 @@
         </p:nvSpPr>
         <p:spPr>
           <a:xfrm>
-            <a:off x="7223760" y="2706624"/>
-            <a:ext cx="4242816" cy="3218688"/>
+            <a:off x="7296912" y="2706624"/>
+            <a:ext cx="4078224" cy="3200400"/>
           </a:xfrm>
           <a:prstGeom prst="rect">
             <a:avLst/>
@@ -21870,7 +21870,7 @@
               </a:spcAft>
             </a:pPr>
             <a:r>
-              <a:rPr sz="1250" b="0">
+              <a:rPr sz="1700" b="0">
                 <a:solidFill>
                   <a:srgbClr val="DCE4F2"/>
                 </a:solidFill>
@@ -22394,7 +22394,7 @@
                 </a:solidFill>
                 <a:latin typeface="Arial"/>
               </a:rPr>
-              <a:t>源码理解支撑</a:t>
+              <a:t>实践含义</a:t>
             </a:r>
           </a:p>
         </p:txBody>
@@ -22407,8 +22407,8 @@
         </p:nvSpPr>
         <p:spPr>
           <a:xfrm>
-            <a:off x="7223760" y="2706624"/>
-            <a:ext cx="4242816" cy="3218688"/>
+            <a:off x="7296912" y="2706624"/>
+            <a:ext cx="4078224" cy="3200400"/>
           </a:xfrm>
           <a:prstGeom prst="rect">
             <a:avLst/>
@@ -22427,7 +22427,7 @@
               </a:spcAft>
             </a:pPr>
             <a:r>
-              <a:rPr sz="1250" b="0">
+              <a:rPr sz="1700" b="0">
                 <a:solidFill>
                   <a:srgbClr val="DCE4F2"/>
                 </a:solidFill>
@@ -22951,7 +22951,7 @@
                 </a:solidFill>
                 <a:latin typeface="Arial"/>
               </a:rPr>
-              <a:t>源码理解支撑</a:t>
+              <a:t>实践含义</a:t>
             </a:r>
           </a:p>
         </p:txBody>
@@ -22964,8 +22964,8 @@
         </p:nvSpPr>
         <p:spPr>
           <a:xfrm>
-            <a:off x="7223760" y="2706624"/>
-            <a:ext cx="4242816" cy="3218688"/>
+            <a:off x="7296912" y="2706624"/>
+            <a:ext cx="4078224" cy="3200400"/>
           </a:xfrm>
           <a:prstGeom prst="rect">
             <a:avLst/>
@@ -22984,7 +22984,7 @@
               </a:spcAft>
             </a:pPr>
             <a:r>
-              <a:rPr sz="1250" b="0">
+              <a:rPr sz="1700" b="0">
                 <a:solidFill>
                   <a:srgbClr val="DCE4F2"/>
                 </a:solidFill>
@@ -23508,7 +23508,7 @@
                 </a:solidFill>
                 <a:latin typeface="Arial"/>
               </a:rPr>
-              <a:t>源码理解支撑</a:t>
+              <a:t>实践含义</a:t>
             </a:r>
           </a:p>
         </p:txBody>
@@ -23521,8 +23521,8 @@
         </p:nvSpPr>
         <p:spPr>
           <a:xfrm>
-            <a:off x="7223760" y="2706624"/>
-            <a:ext cx="4242816" cy="3218688"/>
+            <a:off x="7296912" y="2706624"/>
+            <a:ext cx="4078224" cy="3200400"/>
           </a:xfrm>
           <a:prstGeom prst="rect">
             <a:avLst/>
@@ -23541,7 +23541,7 @@
               </a:spcAft>
             </a:pPr>
             <a:r>
-              <a:rPr sz="1250" b="0">
+              <a:rPr sz="1700" b="0">
                 <a:solidFill>
                   <a:srgbClr val="DCE4F2"/>
                 </a:solidFill>
@@ -25010,7 +25010,7 @@
                 </a:solidFill>
                 <a:latin typeface="Arial"/>
               </a:rPr>
-              <a:t>源码理解支撑</a:t>
+              <a:t>实践含义</a:t>
             </a:r>
           </a:p>
         </p:txBody>
@@ -25023,8 +25023,8 @@
         </p:nvSpPr>
         <p:spPr>
           <a:xfrm>
-            <a:off x="7223760" y="2706624"/>
-            <a:ext cx="4242816" cy="3218688"/>
+            <a:off x="7296912" y="2706624"/>
+            <a:ext cx="4078224" cy="3200400"/>
           </a:xfrm>
           <a:prstGeom prst="rect">
             <a:avLst/>
@@ -25043,7 +25043,7 @@
               </a:spcAft>
             </a:pPr>
             <a:r>
-              <a:rPr sz="1250" b="0">
+              <a:rPr sz="1700" b="0">
                 <a:solidFill>
                   <a:srgbClr val="DCE4F2"/>
                 </a:solidFill>
@@ -25960,7 +25960,7 @@
                 </a:solidFill>
                 <a:latin typeface="Arial"/>
               </a:rPr>
-              <a:t>源码理解支撑</a:t>
+              <a:t>实践含义</a:t>
             </a:r>
           </a:p>
         </p:txBody>
@@ -25973,8 +25973,8 @@
         </p:nvSpPr>
         <p:spPr>
           <a:xfrm>
-            <a:off x="7223760" y="2706624"/>
-            <a:ext cx="4242816" cy="3218688"/>
+            <a:off x="7296912" y="2706624"/>
+            <a:ext cx="4078224" cy="3200400"/>
           </a:xfrm>
           <a:prstGeom prst="rect">
             <a:avLst/>
@@ -25993,7 +25993,7 @@
               </a:spcAft>
             </a:pPr>
             <a:r>
-              <a:rPr sz="1250" b="0">
+              <a:rPr sz="1700" b="0">
                 <a:solidFill>
                   <a:srgbClr val="DCE4F2"/>
                 </a:solidFill>
@@ -26623,7 +26623,7 @@
                 </a:solidFill>
                 <a:latin typeface="Arial"/>
               </a:rPr>
-              <a:t>这段代码说明了什么</a:t>
+              <a:t>这段代码说明什么</a:t>
             </a:r>
           </a:p>
         </p:txBody>
@@ -27286,7 +27286,7 @@
                 </a:solidFill>
                 <a:latin typeface="Arial"/>
               </a:rPr>
-              <a:t>这段代码说明了什么</a:t>
+              <a:t>这段代码说明什么</a:t>
             </a:r>
           </a:p>
         </p:txBody>
@@ -27949,7 +27949,7 @@
                 </a:solidFill>
                 <a:latin typeface="Arial"/>
               </a:rPr>
-              <a:t>这段代码说明了什么</a:t>
+              <a:t>这段代码说明什么</a:t>
             </a:r>
           </a:p>
         </p:txBody>
@@ -28612,7 +28612,7 @@
                 </a:solidFill>
                 <a:latin typeface="Arial"/>
               </a:rPr>
-              <a:t>这段代码说明了什么</a:t>
+              <a:t>这段代码说明什么</a:t>
             </a:r>
           </a:p>
         </p:txBody>
@@ -29275,7 +29275,7 @@
                 </a:solidFill>
                 <a:latin typeface="Arial"/>
               </a:rPr>
-              <a:t>这段代码说明了什么</a:t>
+              <a:t>这段代码说明什么</a:t>
             </a:r>
           </a:p>
         </p:txBody>
@@ -29938,7 +29938,7 @@
                 </a:solidFill>
                 <a:latin typeface="Arial"/>
               </a:rPr>
-              <a:t>这段代码说明了什么</a:t>
+              <a:t>这段代码说明什么</a:t>
             </a:r>
           </a:p>
         </p:txBody>
@@ -30495,7 +30495,7 @@
                 </a:solidFill>
                 <a:latin typeface="Arial"/>
               </a:rPr>
-              <a:t>源码理解支撑</a:t>
+              <a:t>实践含义</a:t>
             </a:r>
           </a:p>
         </p:txBody>
@@ -30508,8 +30508,8 @@
         </p:nvSpPr>
         <p:spPr>
           <a:xfrm>
-            <a:off x="7223760" y="2706624"/>
-            <a:ext cx="4242816" cy="3218688"/>
+            <a:off x="7296912" y="2706624"/>
+            <a:ext cx="4078224" cy="3200400"/>
           </a:xfrm>
           <a:prstGeom prst="rect">
             <a:avLst/>
@@ -30528,7 +30528,7 @@
               </a:spcAft>
             </a:pPr>
             <a:r>
-              <a:rPr sz="1250" b="0">
+              <a:rPr sz="1700" b="0">
                 <a:solidFill>
                   <a:srgbClr val="DCE4F2"/>
                 </a:solidFill>
@@ -31052,7 +31052,7 @@
                 </a:solidFill>
                 <a:latin typeface="Arial"/>
               </a:rPr>
-              <a:t>源码理解支撑</a:t>
+              <a:t>实践含义</a:t>
             </a:r>
           </a:p>
         </p:txBody>
@@ -31065,8 +31065,8 @@
         </p:nvSpPr>
         <p:spPr>
           <a:xfrm>
-            <a:off x="7223760" y="2706624"/>
-            <a:ext cx="4242816" cy="3218688"/>
+            <a:off x="7296912" y="2706624"/>
+            <a:ext cx="4078224" cy="3200400"/>
           </a:xfrm>
           <a:prstGeom prst="rect">
             <a:avLst/>
@@ -31085,7 +31085,7 @@
               </a:spcAft>
             </a:pPr>
             <a:r>
-              <a:rPr sz="1250" b="0">
+              <a:rPr sz="1700" b="0">
                 <a:solidFill>
                   <a:srgbClr val="DCE4F2"/>
                 </a:solidFill>
@@ -31609,7 +31609,7 @@
                 </a:solidFill>
                 <a:latin typeface="Arial"/>
               </a:rPr>
-              <a:t>源码理解支撑</a:t>
+              <a:t>实践含义</a:t>
             </a:r>
           </a:p>
         </p:txBody>
@@ -31622,8 +31622,8 @@
         </p:nvSpPr>
         <p:spPr>
           <a:xfrm>
-            <a:off x="7223760" y="2706624"/>
-            <a:ext cx="4242816" cy="3218688"/>
+            <a:off x="7296912" y="2706624"/>
+            <a:ext cx="4078224" cy="3200400"/>
           </a:xfrm>
           <a:prstGeom prst="rect">
             <a:avLst/>
@@ -31642,7 +31642,7 @@
               </a:spcAft>
             </a:pPr>
             <a:r>
-              <a:rPr sz="1250" b="0">
+              <a:rPr sz="1700" b="0">
                 <a:solidFill>
                   <a:srgbClr val="DCE4F2"/>
                 </a:solidFill>
@@ -32166,7 +32166,7 @@
                 </a:solidFill>
                 <a:latin typeface="Arial"/>
               </a:rPr>
-              <a:t>源码理解支撑</a:t>
+              <a:t>实践含义</a:t>
             </a:r>
           </a:p>
         </p:txBody>
@@ -32179,8 +32179,8 @@
         </p:nvSpPr>
         <p:spPr>
           <a:xfrm>
-            <a:off x="7223760" y="2706624"/>
-            <a:ext cx="4242816" cy="3218688"/>
+            <a:off x="7296912" y="2706624"/>
+            <a:ext cx="4078224" cy="3200400"/>
           </a:xfrm>
           <a:prstGeom prst="rect">
             <a:avLst/>
@@ -32199,7 +32199,7 @@
               </a:spcAft>
             </a:pPr>
             <a:r>
-              <a:rPr sz="1250" b="0">
+              <a:rPr sz="1700" b="0">
                 <a:solidFill>
                   <a:srgbClr val="DCE4F2"/>
                 </a:solidFill>
@@ -32723,7 +32723,7 @@
                 </a:solidFill>
                 <a:latin typeface="Arial"/>
               </a:rPr>
-              <a:t>源码理解支撑</a:t>
+              <a:t>实践含义</a:t>
             </a:r>
           </a:p>
         </p:txBody>
@@ -32736,8 +32736,8 @@
         </p:nvSpPr>
         <p:spPr>
           <a:xfrm>
-            <a:off x="7223760" y="2706624"/>
-            <a:ext cx="4242816" cy="3218688"/>
+            <a:off x="7296912" y="2706624"/>
+            <a:ext cx="4078224" cy="3200400"/>
           </a:xfrm>
           <a:prstGeom prst="rect">
             <a:avLst/>
@@ -32756,7 +32756,7 @@
               </a:spcAft>
             </a:pPr>
             <a:r>
-              <a:rPr sz="1250" b="0">
+              <a:rPr sz="1700" b="0">
                 <a:solidFill>
                   <a:srgbClr val="DCE4F2"/>
                 </a:solidFill>
@@ -33280,7 +33280,7 @@
                 </a:solidFill>
                 <a:latin typeface="Arial"/>
               </a:rPr>
-              <a:t>源码理解支撑</a:t>
+              <a:t>实践含义</a:t>
             </a:r>
           </a:p>
         </p:txBody>
@@ -33293,8 +33293,8 @@
         </p:nvSpPr>
         <p:spPr>
           <a:xfrm>
-            <a:off x="7223760" y="2706624"/>
-            <a:ext cx="4242816" cy="3218688"/>
+            <a:off x="7296912" y="2706624"/>
+            <a:ext cx="4078224" cy="3200400"/>
           </a:xfrm>
           <a:prstGeom prst="rect">
             <a:avLst/>
@@ -33313,7 +33313,7 @@
               </a:spcAft>
             </a:pPr>
             <a:r>
-              <a:rPr sz="1250" b="0">
+              <a:rPr sz="1700" b="0">
                 <a:solidFill>
                   <a:srgbClr val="DCE4F2"/>
                 </a:solidFill>
@@ -33837,7 +33837,7 @@
                 </a:solidFill>
                 <a:latin typeface="Arial"/>
               </a:rPr>
-              <a:t>源码理解支撑</a:t>
+              <a:t>实践含义</a:t>
             </a:r>
           </a:p>
         </p:txBody>
@@ -33850,8 +33850,8 @@
         </p:nvSpPr>
         <p:spPr>
           <a:xfrm>
-            <a:off x="7223760" y="2706624"/>
-            <a:ext cx="4242816" cy="3218688"/>
+            <a:off x="7296912" y="2706624"/>
+            <a:ext cx="4078224" cy="3200400"/>
           </a:xfrm>
           <a:prstGeom prst="rect">
             <a:avLst/>
@@ -33870,7 +33870,7 @@
               </a:spcAft>
             </a:pPr>
             <a:r>
-              <a:rPr sz="1250" b="0">
+              <a:rPr sz="1700" b="0">
                 <a:solidFill>
                   <a:srgbClr val="DCE4F2"/>
                 </a:solidFill>
@@ -34508,7 +34508,7 @@
                 </a:solidFill>
                 <a:latin typeface="Arial"/>
               </a:rPr>
-              <a:t>这段代码说明了什么</a:t>
+              <a:t>这段代码说明什么</a:t>
             </a:r>
           </a:p>
         </p:txBody>
@@ -35065,7 +35065,7 @@
                 </a:solidFill>
                 <a:latin typeface="Arial"/>
               </a:rPr>
-              <a:t>源码理解支撑</a:t>
+              <a:t>实践含义</a:t>
             </a:r>
           </a:p>
         </p:txBody>
@@ -35078,8 +35078,8 @@
         </p:nvSpPr>
         <p:spPr>
           <a:xfrm>
-            <a:off x="7223760" y="2706624"/>
-            <a:ext cx="4242816" cy="3218688"/>
+            <a:off x="7296912" y="2706624"/>
+            <a:ext cx="4078224" cy="3200400"/>
           </a:xfrm>
           <a:prstGeom prst="rect">
             <a:avLst/>
@@ -35098,7 +35098,7 @@
               </a:spcAft>
             </a:pPr>
             <a:r>
-              <a:rPr sz="1250" b="0">
+              <a:rPr sz="1700" b="0">
                 <a:solidFill>
                   <a:srgbClr val="DCE4F2"/>
                 </a:solidFill>
@@ -35622,7 +35622,7 @@
                 </a:solidFill>
                 <a:latin typeface="Arial"/>
               </a:rPr>
-              <a:t>源码理解支撑</a:t>
+              <a:t>实践含义</a:t>
             </a:r>
           </a:p>
         </p:txBody>
@@ -35635,8 +35635,8 @@
         </p:nvSpPr>
         <p:spPr>
           <a:xfrm>
-            <a:off x="7223760" y="2706624"/>
-            <a:ext cx="4242816" cy="3218688"/>
+            <a:off x="7296912" y="2706624"/>
+            <a:ext cx="4078224" cy="3200400"/>
           </a:xfrm>
           <a:prstGeom prst="rect">
             <a:avLst/>
@@ -35655,7 +35655,7 @@
               </a:spcAft>
             </a:pPr>
             <a:r>
-              <a:rPr sz="1250" b="0">
+              <a:rPr sz="1700" b="0">
                 <a:solidFill>
                   <a:srgbClr val="DCE4F2"/>
                 </a:solidFill>

</xml_diff>

<commit_message>
Add code evidence to deep dive deck
</commit_message>
<xml_diff>
--- a/docs/zh/10-Claude Code 源码深度解读.pptx
+++ b/docs/zh/10-Claude Code 源码深度解读.pptx
@@ -6060,7 +6060,118 @@
         <p:spPr>
           <a:xfrm>
             <a:off x="7150608" y="2359152"/>
-            <a:ext cx="4389120" cy="3639312"/>
+            <a:ext cx="4389120" cy="1554480"/>
+          </a:xfrm>
+          <a:prstGeom prst="roundRect">
+            <a:avLst/>
+          </a:prstGeom>
+          <a:solidFill>
+            <a:srgbClr val="040C1C"/>
+          </a:solidFill>
+          <a:ln>
+            <a:solidFill>
+              <a:srgbClr val="38BDF8"/>
+            </a:solidFill>
+          </a:ln>
+        </p:spPr>
+        <p:style>
+          <a:lnRef idx="1">
+            <a:schemeClr val="accent1"/>
+          </a:lnRef>
+          <a:fillRef idx="3">
+            <a:schemeClr val="accent1"/>
+          </a:fillRef>
+          <a:effectRef idx="2">
+            <a:schemeClr val="accent1"/>
+          </a:effectRef>
+          <a:fontRef idx="minor">
+            <a:schemeClr val="lt1"/>
+          </a:fontRef>
+        </p:style>
+        <p:txBody>
+          <a:bodyPr rtlCol="0" anchor="t" wrap="square" tIns="190500" bIns="76200" lIns="127000" rIns="127000"/>
+          <a:lstStyle/>
+          <a:p>
+            <a:pPr algn="ctr"/>
+            <a:r>
+              <a:rPr sz="1150" b="0">
+                <a:solidFill>
+                  <a:srgbClr val="BBF7FF"/>
+                </a:solidFill>
+                <a:latin typeface="Courier New"/>
+              </a:rPr>
+              <a:t>type State = {
+  messages: Message[]
+  toolUseContext: ToolUseContext
+  turnCount: number
+  transition: Continue | undefined
+}</a:t>
+            </a:r>
+          </a:p>
+        </p:txBody>
+      </p:sp>
+      <p:sp>
+        <p:nvSpPr>
+          <p:cNvPr id="10" name="Rectangle 9"/>
+          <p:cNvSpPr/>
+          <p:nvPr/>
+        </p:nvSpPr>
+        <p:spPr>
+          <a:xfrm>
+            <a:off x="7150608" y="2359152"/>
+            <a:ext cx="4389120" cy="256032"/>
+          </a:xfrm>
+          <a:prstGeom prst="rect">
+            <a:avLst/>
+          </a:prstGeom>
+          <a:solidFill>
+            <a:srgbClr val="0C1B38"/>
+          </a:solidFill>
+          <a:ln>
+            <a:noFill/>
+          </a:ln>
+        </p:spPr>
+        <p:style>
+          <a:lnRef idx="1">
+            <a:schemeClr val="accent1"/>
+          </a:lnRef>
+          <a:fillRef idx="3">
+            <a:schemeClr val="accent1"/>
+          </a:fillRef>
+          <a:effectRef idx="2">
+            <a:schemeClr val="accent1"/>
+          </a:effectRef>
+          <a:fontRef idx="minor">
+            <a:schemeClr val="lt1"/>
+          </a:fontRef>
+        </p:style>
+        <p:txBody>
+          <a:bodyPr rtlCol="0" anchor="t" wrap="square" tIns="12700" bIns="12700" lIns="76200" rIns="76200"/>
+          <a:lstStyle/>
+          <a:p>
+            <a:pPr algn="ctr"/>
+            <a:r>
+              <a:rPr sz="1000" b="1">
+                <a:solidFill>
+                  <a:srgbClr val="38BDF8"/>
+                </a:solidFill>
+                <a:latin typeface="Courier New"/>
+              </a:rPr>
+              <a:t>源码代码</a:t>
+            </a:r>
+          </a:p>
+        </p:txBody>
+      </p:sp>
+      <p:sp>
+        <p:nvSpPr>
+          <p:cNvPr id="11" name="Rounded Rectangle 10"/>
+          <p:cNvSpPr/>
+          <p:nvPr/>
+        </p:nvSpPr>
+        <p:spPr>
+          <a:xfrm>
+            <a:off x="7150608" y="4059936"/>
+            <a:ext cx="4389120" cy="1938528"/>
           </a:xfrm>
           <a:prstGeom prst="roundRect">
             <a:avLst/>
@@ -6098,13 +6209,13 @@
       </p:sp>
       <p:sp>
         <p:nvSpPr>
-          <p:cNvPr id="10" name="Rectangle 9"/>
-          <p:cNvSpPr/>
-          <p:nvPr/>
-        </p:nvSpPr>
-        <p:spPr>
-          <a:xfrm>
-            <a:off x="7150608" y="2359152"/>
+          <p:cNvPr id="12" name="Rectangle 11"/>
+          <p:cNvSpPr/>
+          <p:nvPr/>
+        </p:nvSpPr>
+        <p:spPr>
+          <a:xfrm>
+            <a:off x="7150608" y="4059936"/>
             <a:ext cx="4389120" cy="310896"/>
           </a:xfrm>
           <a:prstGeom prst="rect">
@@ -6143,21 +6254,21 @@
                 </a:solidFill>
                 <a:latin typeface="Arial"/>
               </a:rPr>
-              <a:t>实践含义</a:t>
-            </a:r>
-          </a:p>
-        </p:txBody>
-      </p:sp>
-      <p:sp>
-        <p:nvSpPr>
-          <p:cNvPr id="11" name="TextBox 10"/>
+              <a:t>这段代码说明什么</a:t>
+            </a:r>
+          </a:p>
+        </p:txBody>
+      </p:sp>
+      <p:sp>
+        <p:nvSpPr>
+          <p:cNvPr id="13" name="TextBox 12"/>
           <p:cNvSpPr txBox="1"/>
           <p:nvPr/>
         </p:nvSpPr>
         <p:spPr>
           <a:xfrm>
-            <a:off x="7296912" y="2706624"/>
-            <a:ext cx="4078224" cy="3200400"/>
+            <a:off x="7223760" y="4407408"/>
+            <a:ext cx="4242816" cy="1517904"/>
           </a:xfrm>
           <a:prstGeom prst="rect">
             <a:avLst/>
@@ -6176,7 +6287,7 @@
               </a:spcAft>
             </a:pPr>
             <a:r>
-              <a:rPr sz="1700" b="0">
+              <a:rPr sz="1250" b="0">
                 <a:solidFill>
                   <a:srgbClr val="DCE4F2"/>
                 </a:solidFill>
@@ -6189,7 +6300,7 @@
       </p:sp>
       <p:sp>
         <p:nvSpPr>
-          <p:cNvPr id="12" name="TextBox 11"/>
+          <p:cNvPr id="14" name="TextBox 13"/>
           <p:cNvSpPr txBox="1"/>
           <p:nvPr/>
         </p:nvSpPr>
@@ -7174,7 +7285,117 @@
         <p:spPr>
           <a:xfrm>
             <a:off x="7150608" y="2359152"/>
-            <a:ext cx="4389120" cy="3639312"/>
+            <a:ext cx="4389120" cy="1554480"/>
+          </a:xfrm>
+          <a:prstGeom prst="roundRect">
+            <a:avLst/>
+          </a:prstGeom>
+          <a:solidFill>
+            <a:srgbClr val="040C1C"/>
+          </a:solidFill>
+          <a:ln>
+            <a:solidFill>
+              <a:srgbClr val="38BDF8"/>
+            </a:solidFill>
+          </a:ln>
+        </p:spPr>
+        <p:style>
+          <a:lnRef idx="1">
+            <a:schemeClr val="accent1"/>
+          </a:lnRef>
+          <a:fillRef idx="3">
+            <a:schemeClr val="accent1"/>
+          </a:fillRef>
+          <a:effectRef idx="2">
+            <a:schemeClr val="accent1"/>
+          </a:effectRef>
+          <a:fontRef idx="minor">
+            <a:schemeClr val="lt1"/>
+          </a:fontRef>
+        </p:style>
+        <p:txBody>
+          <a:bodyPr rtlCol="0" anchor="t" wrap="square" tIns="190500" bIns="76200" lIns="127000" rIns="127000"/>
+          <a:lstStyle/>
+          <a:p>
+            <a:pPr algn="ctr"/>
+            <a:r>
+              <a:rPr sz="1150" b="0">
+                <a:solidFill>
+                  <a:srgbClr val="BBF7FF"/>
+                </a:solidFill>
+                <a:latin typeface="Courier New"/>
+              </a:rPr>
+              <a:t>function getCriticalSystemReminderAttachment(...) {
+  const reminder = toolUseContext.criticalSystemReminder_EXPERIMENTAL
+  if (!reminder) return []
+  return [{ type: 'critical_system_reminder', content: reminder }]
+}</a:t>
+            </a:r>
+          </a:p>
+        </p:txBody>
+      </p:sp>
+      <p:sp>
+        <p:nvSpPr>
+          <p:cNvPr id="10" name="Rectangle 9"/>
+          <p:cNvSpPr/>
+          <p:nvPr/>
+        </p:nvSpPr>
+        <p:spPr>
+          <a:xfrm>
+            <a:off x="7150608" y="2359152"/>
+            <a:ext cx="4389120" cy="256032"/>
+          </a:xfrm>
+          <a:prstGeom prst="rect">
+            <a:avLst/>
+          </a:prstGeom>
+          <a:solidFill>
+            <a:srgbClr val="0C1B38"/>
+          </a:solidFill>
+          <a:ln>
+            <a:noFill/>
+          </a:ln>
+        </p:spPr>
+        <p:style>
+          <a:lnRef idx="1">
+            <a:schemeClr val="accent1"/>
+          </a:lnRef>
+          <a:fillRef idx="3">
+            <a:schemeClr val="accent1"/>
+          </a:fillRef>
+          <a:effectRef idx="2">
+            <a:schemeClr val="accent1"/>
+          </a:effectRef>
+          <a:fontRef idx="minor">
+            <a:schemeClr val="lt1"/>
+          </a:fontRef>
+        </p:style>
+        <p:txBody>
+          <a:bodyPr rtlCol="0" anchor="t" wrap="square" tIns="12700" bIns="12700" lIns="76200" rIns="76200"/>
+          <a:lstStyle/>
+          <a:p>
+            <a:pPr algn="ctr"/>
+            <a:r>
+              <a:rPr sz="1000" b="1">
+                <a:solidFill>
+                  <a:srgbClr val="38BDF8"/>
+                </a:solidFill>
+                <a:latin typeface="Courier New"/>
+              </a:rPr>
+              <a:t>源码代码</a:t>
+            </a:r>
+          </a:p>
+        </p:txBody>
+      </p:sp>
+      <p:sp>
+        <p:nvSpPr>
+          <p:cNvPr id="11" name="Rounded Rectangle 10"/>
+          <p:cNvSpPr/>
+          <p:nvPr/>
+        </p:nvSpPr>
+        <p:spPr>
+          <a:xfrm>
+            <a:off x="7150608" y="4059936"/>
+            <a:ext cx="4389120" cy="1938528"/>
           </a:xfrm>
           <a:prstGeom prst="roundRect">
             <a:avLst/>
@@ -7212,13 +7433,13 @@
       </p:sp>
       <p:sp>
         <p:nvSpPr>
-          <p:cNvPr id="10" name="Rectangle 9"/>
-          <p:cNvSpPr/>
-          <p:nvPr/>
-        </p:nvSpPr>
-        <p:spPr>
-          <a:xfrm>
-            <a:off x="7150608" y="2359152"/>
+          <p:cNvPr id="12" name="Rectangle 11"/>
+          <p:cNvSpPr/>
+          <p:nvPr/>
+        </p:nvSpPr>
+        <p:spPr>
+          <a:xfrm>
+            <a:off x="7150608" y="4059936"/>
             <a:ext cx="4389120" cy="310896"/>
           </a:xfrm>
           <a:prstGeom prst="rect">
@@ -7257,21 +7478,21 @@
                 </a:solidFill>
                 <a:latin typeface="Arial"/>
               </a:rPr>
-              <a:t>实践含义</a:t>
-            </a:r>
-          </a:p>
-        </p:txBody>
-      </p:sp>
-      <p:sp>
-        <p:nvSpPr>
-          <p:cNvPr id="11" name="TextBox 10"/>
+              <a:t>这段代码说明什么</a:t>
+            </a:r>
+          </a:p>
+        </p:txBody>
+      </p:sp>
+      <p:sp>
+        <p:nvSpPr>
+          <p:cNvPr id="13" name="TextBox 12"/>
           <p:cNvSpPr txBox="1"/>
           <p:nvPr/>
         </p:nvSpPr>
         <p:spPr>
           <a:xfrm>
-            <a:off x="7296912" y="2706624"/>
-            <a:ext cx="4078224" cy="3200400"/>
+            <a:off x="7223760" y="4407408"/>
+            <a:ext cx="4242816" cy="1517904"/>
           </a:xfrm>
           <a:prstGeom prst="rect">
             <a:avLst/>
@@ -7290,7 +7511,7 @@
               </a:spcAft>
             </a:pPr>
             <a:r>
-              <a:rPr sz="1700" b="0">
+              <a:rPr sz="1250" b="0">
                 <a:solidFill>
                   <a:srgbClr val="DCE4F2"/>
                 </a:solidFill>
@@ -7303,7 +7524,7 @@
       </p:sp>
       <p:sp>
         <p:nvSpPr>
-          <p:cNvPr id="12" name="TextBox 11"/>
+          <p:cNvPr id="14" name="TextBox 13"/>
           <p:cNvSpPr txBox="1"/>
           <p:nvPr/>
         </p:nvSpPr>
@@ -8400,7 +8621,115 @@
         <p:spPr>
           <a:xfrm>
             <a:off x="7150608" y="2359152"/>
-            <a:ext cx="4389120" cy="3639312"/>
+            <a:ext cx="4389120" cy="1554480"/>
+          </a:xfrm>
+          <a:prstGeom prst="roundRect">
+            <a:avLst/>
+          </a:prstGeom>
+          <a:solidFill>
+            <a:srgbClr val="040C1C"/>
+          </a:solidFill>
+          <a:ln>
+            <a:solidFill>
+              <a:srgbClr val="38BDF8"/>
+            </a:solidFill>
+          </a:ln>
+        </p:spPr>
+        <p:style>
+          <a:lnRef idx="1">
+            <a:schemeClr val="accent1"/>
+          </a:lnRef>
+          <a:fillRef idx="3">
+            <a:schemeClr val="accent1"/>
+          </a:fillRef>
+          <a:effectRef idx="2">
+            <a:schemeClr val="accent1"/>
+          </a:effectRef>
+          <a:fontRef idx="minor">
+            <a:schemeClr val="lt1"/>
+          </a:fontRef>
+        </p:style>
+        <p:txBody>
+          <a:bodyPr rtlCol="0" anchor="t" wrap="square" tIns="190500" bIns="76200" lIns="127000" rIns="127000"/>
+          <a:lstStyle/>
+          <a:p>
+            <a:pPr algn="ctr"/>
+            <a:r>
+              <a:rPr sz="1150" b="0">
+                <a:solidFill>
+                  <a:srgbClr val="BBF7FF"/>
+                </a:solidFill>
+                <a:latin typeface="Courier New"/>
+              </a:rPr>
+              <a:t>const filteredToolUses = filterUnresolvedToolUses(migratedMessages)
+const filteredThinking =
+  filterOrphanedThinkingOnlyMessages(filteredToolUses)</a:t>
+            </a:r>
+          </a:p>
+        </p:txBody>
+      </p:sp>
+      <p:sp>
+        <p:nvSpPr>
+          <p:cNvPr id="10" name="Rectangle 9"/>
+          <p:cNvSpPr/>
+          <p:nvPr/>
+        </p:nvSpPr>
+        <p:spPr>
+          <a:xfrm>
+            <a:off x="7150608" y="2359152"/>
+            <a:ext cx="4389120" cy="256032"/>
+          </a:xfrm>
+          <a:prstGeom prst="rect">
+            <a:avLst/>
+          </a:prstGeom>
+          <a:solidFill>
+            <a:srgbClr val="0C1B38"/>
+          </a:solidFill>
+          <a:ln>
+            <a:noFill/>
+          </a:ln>
+        </p:spPr>
+        <p:style>
+          <a:lnRef idx="1">
+            <a:schemeClr val="accent1"/>
+          </a:lnRef>
+          <a:fillRef idx="3">
+            <a:schemeClr val="accent1"/>
+          </a:fillRef>
+          <a:effectRef idx="2">
+            <a:schemeClr val="accent1"/>
+          </a:effectRef>
+          <a:fontRef idx="minor">
+            <a:schemeClr val="lt1"/>
+          </a:fontRef>
+        </p:style>
+        <p:txBody>
+          <a:bodyPr rtlCol="0" anchor="t" wrap="square" tIns="12700" bIns="12700" lIns="76200" rIns="76200"/>
+          <a:lstStyle/>
+          <a:p>
+            <a:pPr algn="ctr"/>
+            <a:r>
+              <a:rPr sz="1000" b="1">
+                <a:solidFill>
+                  <a:srgbClr val="38BDF8"/>
+                </a:solidFill>
+                <a:latin typeface="Courier New"/>
+              </a:rPr>
+              <a:t>源码代码</a:t>
+            </a:r>
+          </a:p>
+        </p:txBody>
+      </p:sp>
+      <p:sp>
+        <p:nvSpPr>
+          <p:cNvPr id="11" name="Rounded Rectangle 10"/>
+          <p:cNvSpPr/>
+          <p:nvPr/>
+        </p:nvSpPr>
+        <p:spPr>
+          <a:xfrm>
+            <a:off x="7150608" y="4059936"/>
+            <a:ext cx="4389120" cy="1938528"/>
           </a:xfrm>
           <a:prstGeom prst="roundRect">
             <a:avLst/>
@@ -8438,13 +8767,13 @@
       </p:sp>
       <p:sp>
         <p:nvSpPr>
-          <p:cNvPr id="10" name="Rectangle 9"/>
-          <p:cNvSpPr/>
-          <p:nvPr/>
-        </p:nvSpPr>
-        <p:spPr>
-          <a:xfrm>
-            <a:off x="7150608" y="2359152"/>
+          <p:cNvPr id="12" name="Rectangle 11"/>
+          <p:cNvSpPr/>
+          <p:nvPr/>
+        </p:nvSpPr>
+        <p:spPr>
+          <a:xfrm>
+            <a:off x="7150608" y="4059936"/>
             <a:ext cx="4389120" cy="310896"/>
           </a:xfrm>
           <a:prstGeom prst="rect">
@@ -8483,21 +8812,21 @@
                 </a:solidFill>
                 <a:latin typeface="Arial"/>
               </a:rPr>
-              <a:t>实践含义</a:t>
-            </a:r>
-          </a:p>
-        </p:txBody>
-      </p:sp>
-      <p:sp>
-        <p:nvSpPr>
-          <p:cNvPr id="11" name="TextBox 10"/>
+              <a:t>这段代码说明什么</a:t>
+            </a:r>
+          </a:p>
+        </p:txBody>
+      </p:sp>
+      <p:sp>
+        <p:nvSpPr>
+          <p:cNvPr id="13" name="TextBox 12"/>
           <p:cNvSpPr txBox="1"/>
           <p:nvPr/>
         </p:nvSpPr>
         <p:spPr>
           <a:xfrm>
-            <a:off x="7296912" y="2706624"/>
-            <a:ext cx="4078224" cy="3200400"/>
+            <a:off x="7223760" y="4407408"/>
+            <a:ext cx="4242816" cy="1517904"/>
           </a:xfrm>
           <a:prstGeom prst="rect">
             <a:avLst/>
@@ -8516,7 +8845,7 @@
               </a:spcAft>
             </a:pPr>
             <a:r>
-              <a:rPr sz="1700" b="0">
+              <a:rPr sz="1250" b="0">
                 <a:solidFill>
                   <a:srgbClr val="DCE4F2"/>
                 </a:solidFill>
@@ -8529,7 +8858,7 @@
       </p:sp>
       <p:sp>
         <p:nvSpPr>
-          <p:cNvPr id="12" name="TextBox 11"/>
+          <p:cNvPr id="14" name="TextBox 13"/>
           <p:cNvSpPr txBox="1"/>
           <p:nvPr/>
         </p:nvSpPr>
@@ -13464,7 +13793,113 @@
         <p:spPr>
           <a:xfrm>
             <a:off x="7150608" y="2359152"/>
-            <a:ext cx="4389120" cy="3639312"/>
+            <a:ext cx="4389120" cy="1554480"/>
+          </a:xfrm>
+          <a:prstGeom prst="roundRect">
+            <a:avLst/>
+          </a:prstGeom>
+          <a:solidFill>
+            <a:srgbClr val="040C1C"/>
+          </a:solidFill>
+          <a:ln>
+            <a:solidFill>
+              <a:srgbClr val="38BDF8"/>
+            </a:solidFill>
+          </a:ln>
+        </p:spPr>
+        <p:style>
+          <a:lnRef idx="1">
+            <a:schemeClr val="accent1"/>
+          </a:lnRef>
+          <a:fillRef idx="3">
+            <a:schemeClr val="accent1"/>
+          </a:fillRef>
+          <a:effectRef idx="2">
+            <a:schemeClr val="accent1"/>
+          </a:effectRef>
+          <a:fontRef idx="minor">
+            <a:schemeClr val="lt1"/>
+          </a:fontRef>
+        </p:style>
+        <p:txBody>
+          <a:bodyPr rtlCol="0" anchor="t" wrap="square" tIns="190500" bIns="76200" lIns="127000" rIns="127000"/>
+          <a:lstStyle/>
+          <a:p>
+            <a:pPr algn="ctr"/>
+            <a:r>
+              <a:rPr sz="1150" b="0">
+                <a:solidFill>
+                  <a:srgbClr val="BBF7FF"/>
+                </a:solidFill>
+                <a:latin typeface="Courier New"/>
+              </a:rPr>
+              <a:t>The user will primarily request you to perform software engineering tasks.</a:t>
+            </a:r>
+          </a:p>
+        </p:txBody>
+      </p:sp>
+      <p:sp>
+        <p:nvSpPr>
+          <p:cNvPr id="10" name="Rectangle 9"/>
+          <p:cNvSpPr/>
+          <p:nvPr/>
+        </p:nvSpPr>
+        <p:spPr>
+          <a:xfrm>
+            <a:off x="7150608" y="2359152"/>
+            <a:ext cx="4389120" cy="256032"/>
+          </a:xfrm>
+          <a:prstGeom prst="rect">
+            <a:avLst/>
+          </a:prstGeom>
+          <a:solidFill>
+            <a:srgbClr val="0C1B38"/>
+          </a:solidFill>
+          <a:ln>
+            <a:noFill/>
+          </a:ln>
+        </p:spPr>
+        <p:style>
+          <a:lnRef idx="1">
+            <a:schemeClr val="accent1"/>
+          </a:lnRef>
+          <a:fillRef idx="3">
+            <a:schemeClr val="accent1"/>
+          </a:fillRef>
+          <a:effectRef idx="2">
+            <a:schemeClr val="accent1"/>
+          </a:effectRef>
+          <a:fontRef idx="minor">
+            <a:schemeClr val="lt1"/>
+          </a:fontRef>
+        </p:style>
+        <p:txBody>
+          <a:bodyPr rtlCol="0" anchor="t" wrap="square" tIns="12700" bIns="12700" lIns="76200" rIns="76200"/>
+          <a:lstStyle/>
+          <a:p>
+            <a:pPr algn="ctr"/>
+            <a:r>
+              <a:rPr sz="1000" b="1">
+                <a:solidFill>
+                  <a:srgbClr val="38BDF8"/>
+                </a:solidFill>
+                <a:latin typeface="Courier New"/>
+              </a:rPr>
+              <a:t>源码提示词</a:t>
+            </a:r>
+          </a:p>
+        </p:txBody>
+      </p:sp>
+      <p:sp>
+        <p:nvSpPr>
+          <p:cNvPr id="11" name="Rounded Rectangle 10"/>
+          <p:cNvSpPr/>
+          <p:nvPr/>
+        </p:nvSpPr>
+        <p:spPr>
+          <a:xfrm>
+            <a:off x="7150608" y="4059936"/>
+            <a:ext cx="4389120" cy="1938528"/>
           </a:xfrm>
           <a:prstGeom prst="roundRect">
             <a:avLst/>
@@ -13502,13 +13937,13 @@
       </p:sp>
       <p:sp>
         <p:nvSpPr>
-          <p:cNvPr id="10" name="Rectangle 9"/>
-          <p:cNvSpPr/>
-          <p:nvPr/>
-        </p:nvSpPr>
-        <p:spPr>
-          <a:xfrm>
-            <a:off x="7150608" y="2359152"/>
+          <p:cNvPr id="12" name="Rectangle 11"/>
+          <p:cNvSpPr/>
+          <p:nvPr/>
+        </p:nvSpPr>
+        <p:spPr>
+          <a:xfrm>
+            <a:off x="7150608" y="4059936"/>
             <a:ext cx="4389120" cy="310896"/>
           </a:xfrm>
           <a:prstGeom prst="rect">
@@ -13547,21 +13982,21 @@
                 </a:solidFill>
                 <a:latin typeface="Arial"/>
               </a:rPr>
-              <a:t>实践含义</a:t>
-            </a:r>
-          </a:p>
-        </p:txBody>
-      </p:sp>
-      <p:sp>
-        <p:nvSpPr>
-          <p:cNvPr id="11" name="TextBox 10"/>
+              <a:t>这段代码说明什么</a:t>
+            </a:r>
+          </a:p>
+        </p:txBody>
+      </p:sp>
+      <p:sp>
+        <p:nvSpPr>
+          <p:cNvPr id="13" name="TextBox 12"/>
           <p:cNvSpPr txBox="1"/>
           <p:nvPr/>
         </p:nvSpPr>
         <p:spPr>
           <a:xfrm>
-            <a:off x="7296912" y="2706624"/>
-            <a:ext cx="4078224" cy="3200400"/>
+            <a:off x="7223760" y="4407408"/>
+            <a:ext cx="4242816" cy="1517904"/>
           </a:xfrm>
           <a:prstGeom prst="rect">
             <a:avLst/>
@@ -13580,7 +14015,7 @@
               </a:spcAft>
             </a:pPr>
             <a:r>
-              <a:rPr sz="1700" b="0">
+              <a:rPr sz="1250" b="0">
                 <a:solidFill>
                   <a:srgbClr val="DCE4F2"/>
                 </a:solidFill>
@@ -13593,7 +14028,7 @@
       </p:sp>
       <p:sp>
         <p:nvSpPr>
-          <p:cNvPr id="12" name="TextBox 11"/>
+          <p:cNvPr id="14" name="TextBox 13"/>
           <p:cNvSpPr txBox="1"/>
           <p:nvPr/>
         </p:nvSpPr>
@@ -17638,7 +18073,120 @@
         <p:spPr>
           <a:xfrm>
             <a:off x="7150608" y="2359152"/>
-            <a:ext cx="4389120" cy="3639312"/>
+            <a:ext cx="4389120" cy="1554480"/>
+          </a:xfrm>
+          <a:prstGeom prst="roundRect">
+            <a:avLst/>
+          </a:prstGeom>
+          <a:solidFill>
+            <a:srgbClr val="040C1C"/>
+          </a:solidFill>
+          <a:ln>
+            <a:solidFill>
+              <a:srgbClr val="38BDF8"/>
+            </a:solidFill>
+          </a:ln>
+        </p:spPr>
+        <p:style>
+          <a:lnRef idx="1">
+            <a:schemeClr val="accent1"/>
+          </a:lnRef>
+          <a:fillRef idx="3">
+            <a:schemeClr val="accent1"/>
+          </a:fillRef>
+          <a:effectRef idx="2">
+            <a:schemeClr val="accent1"/>
+          </a:effectRef>
+          <a:fontRef idx="minor">
+            <a:schemeClr val="lt1"/>
+          </a:fontRef>
+        </p:style>
+        <p:txBody>
+          <a:bodyPr rtlCol="0" anchor="t" wrap="square" tIns="190500" bIns="76200" lIns="127000" rIns="127000"/>
+          <a:lstStyle/>
+          <a:p>
+            <a:pPr algn="ctr"/>
+            <a:r>
+              <a:rPr sz="1150" b="0">
+                <a:solidFill>
+                  <a:srgbClr val="BBF7FF"/>
+                </a:solidFill>
+                <a:latin typeface="Courier New"/>
+              </a:rPr>
+              <a:t>export class QueryEngine {
+  private mutableMessages: Message[]
+}
+type State = {
+  messages: Message[]
+  toolUseContext: ToolUseContext
+  transition: Continue | undefined
+}</a:t>
+            </a:r>
+          </a:p>
+        </p:txBody>
+      </p:sp>
+      <p:sp>
+        <p:nvSpPr>
+          <p:cNvPr id="10" name="Rectangle 9"/>
+          <p:cNvSpPr/>
+          <p:nvPr/>
+        </p:nvSpPr>
+        <p:spPr>
+          <a:xfrm>
+            <a:off x="7150608" y="2359152"/>
+            <a:ext cx="4389120" cy="256032"/>
+          </a:xfrm>
+          <a:prstGeom prst="rect">
+            <a:avLst/>
+          </a:prstGeom>
+          <a:solidFill>
+            <a:srgbClr val="0C1B38"/>
+          </a:solidFill>
+          <a:ln>
+            <a:noFill/>
+          </a:ln>
+        </p:spPr>
+        <p:style>
+          <a:lnRef idx="1">
+            <a:schemeClr val="accent1"/>
+          </a:lnRef>
+          <a:fillRef idx="3">
+            <a:schemeClr val="accent1"/>
+          </a:fillRef>
+          <a:effectRef idx="2">
+            <a:schemeClr val="accent1"/>
+          </a:effectRef>
+          <a:fontRef idx="minor">
+            <a:schemeClr val="lt1"/>
+          </a:fontRef>
+        </p:style>
+        <p:txBody>
+          <a:bodyPr rtlCol="0" anchor="t" wrap="square" tIns="12700" bIns="12700" lIns="76200" rIns="76200"/>
+          <a:lstStyle/>
+          <a:p>
+            <a:pPr algn="ctr"/>
+            <a:r>
+              <a:rPr sz="1000" b="1">
+                <a:solidFill>
+                  <a:srgbClr val="38BDF8"/>
+                </a:solidFill>
+                <a:latin typeface="Courier New"/>
+              </a:rPr>
+              <a:t>源码代码</a:t>
+            </a:r>
+          </a:p>
+        </p:txBody>
+      </p:sp>
+      <p:sp>
+        <p:nvSpPr>
+          <p:cNvPr id="11" name="Rounded Rectangle 10"/>
+          <p:cNvSpPr/>
+          <p:nvPr/>
+        </p:nvSpPr>
+        <p:spPr>
+          <a:xfrm>
+            <a:off x="7150608" y="4059936"/>
+            <a:ext cx="4389120" cy="1938528"/>
           </a:xfrm>
           <a:prstGeom prst="roundRect">
             <a:avLst/>
@@ -17676,13 +18224,13 @@
       </p:sp>
       <p:sp>
         <p:nvSpPr>
-          <p:cNvPr id="10" name="Rectangle 9"/>
-          <p:cNvSpPr/>
-          <p:nvPr/>
-        </p:nvSpPr>
-        <p:spPr>
-          <a:xfrm>
-            <a:off x="7150608" y="2359152"/>
+          <p:cNvPr id="12" name="Rectangle 11"/>
+          <p:cNvSpPr/>
+          <p:nvPr/>
+        </p:nvSpPr>
+        <p:spPr>
+          <a:xfrm>
+            <a:off x="7150608" y="4059936"/>
             <a:ext cx="4389120" cy="310896"/>
           </a:xfrm>
           <a:prstGeom prst="rect">
@@ -17721,21 +18269,21 @@
                 </a:solidFill>
                 <a:latin typeface="Arial"/>
               </a:rPr>
-              <a:t>实践含义</a:t>
-            </a:r>
-          </a:p>
-        </p:txBody>
-      </p:sp>
-      <p:sp>
-        <p:nvSpPr>
-          <p:cNvPr id="11" name="TextBox 10"/>
+              <a:t>这段代码说明什么</a:t>
+            </a:r>
+          </a:p>
+        </p:txBody>
+      </p:sp>
+      <p:sp>
+        <p:nvSpPr>
+          <p:cNvPr id="13" name="TextBox 12"/>
           <p:cNvSpPr txBox="1"/>
           <p:nvPr/>
         </p:nvSpPr>
         <p:spPr>
           <a:xfrm>
-            <a:off x="7296912" y="2706624"/>
-            <a:ext cx="4078224" cy="3200400"/>
+            <a:off x="7223760" y="4407408"/>
+            <a:ext cx="4242816" cy="1517904"/>
           </a:xfrm>
           <a:prstGeom prst="rect">
             <a:avLst/>
@@ -17754,7 +18302,7 @@
               </a:spcAft>
             </a:pPr>
             <a:r>
-              <a:rPr sz="1700" b="0">
+              <a:rPr sz="1250" b="0">
                 <a:solidFill>
                   <a:srgbClr val="DCE4F2"/>
                 </a:solidFill>
@@ -17767,7 +18315,7 @@
       </p:sp>
       <p:sp>
         <p:nvSpPr>
-          <p:cNvPr id="12" name="TextBox 11"/>
+          <p:cNvPr id="14" name="TextBox 13"/>
           <p:cNvSpPr txBox="1"/>
           <p:nvPr/>
         </p:nvSpPr>
@@ -25877,7 +26425,114 @@
         <p:spPr>
           <a:xfrm>
             <a:off x="7150608" y="2359152"/>
-            <a:ext cx="4389120" cy="3639312"/>
+            <a:ext cx="4389120" cy="1554480"/>
+          </a:xfrm>
+          <a:prstGeom prst="roundRect">
+            <a:avLst/>
+          </a:prstGeom>
+          <a:solidFill>
+            <a:srgbClr val="040C1C"/>
+          </a:solidFill>
+          <a:ln>
+            <a:solidFill>
+              <a:srgbClr val="38BDF8"/>
+            </a:solidFill>
+          </a:ln>
+        </p:spPr>
+        <p:style>
+          <a:lnRef idx="1">
+            <a:schemeClr val="accent1"/>
+          </a:lnRef>
+          <a:fillRef idx="3">
+            <a:schemeClr val="accent1"/>
+          </a:fillRef>
+          <a:effectRef idx="2">
+            <a:schemeClr val="accent1"/>
+          </a:effectRef>
+          <a:fontRef idx="minor">
+            <a:schemeClr val="lt1"/>
+          </a:fontRef>
+        </p:style>
+        <p:txBody>
+          <a:bodyPr rtlCol="0" anchor="t" wrap="square" tIns="190500" bIns="76200" lIns="127000" rIns="127000"/>
+          <a:lstStyle/>
+          <a:p>
+            <a:pPr algn="ctr"/>
+            <a:r>
+              <a:rPr sz="1150" b="0">
+                <a:solidFill>
+                  <a:srgbClr val="BBF7FF"/>
+                </a:solidFill>
+                <a:latin typeface="Courier New"/>
+              </a:rPr>
+              <a:t>Report outcomes faithfully...
+Carefully consider the reversibility and blast radius of actions.</a:t>
+            </a:r>
+          </a:p>
+        </p:txBody>
+      </p:sp>
+      <p:sp>
+        <p:nvSpPr>
+          <p:cNvPr id="10" name="Rectangle 9"/>
+          <p:cNvSpPr/>
+          <p:nvPr/>
+        </p:nvSpPr>
+        <p:spPr>
+          <a:xfrm>
+            <a:off x="7150608" y="2359152"/>
+            <a:ext cx="4389120" cy="256032"/>
+          </a:xfrm>
+          <a:prstGeom prst="rect">
+            <a:avLst/>
+          </a:prstGeom>
+          <a:solidFill>
+            <a:srgbClr val="0C1B38"/>
+          </a:solidFill>
+          <a:ln>
+            <a:noFill/>
+          </a:ln>
+        </p:spPr>
+        <p:style>
+          <a:lnRef idx="1">
+            <a:schemeClr val="accent1"/>
+          </a:lnRef>
+          <a:fillRef idx="3">
+            <a:schemeClr val="accent1"/>
+          </a:fillRef>
+          <a:effectRef idx="2">
+            <a:schemeClr val="accent1"/>
+          </a:effectRef>
+          <a:fontRef idx="minor">
+            <a:schemeClr val="lt1"/>
+          </a:fontRef>
+        </p:style>
+        <p:txBody>
+          <a:bodyPr rtlCol="0" anchor="t" wrap="square" tIns="12700" bIns="12700" lIns="76200" rIns="76200"/>
+          <a:lstStyle/>
+          <a:p>
+            <a:pPr algn="ctr"/>
+            <a:r>
+              <a:rPr sz="1000" b="1">
+                <a:solidFill>
+                  <a:srgbClr val="38BDF8"/>
+                </a:solidFill>
+                <a:latin typeface="Courier New"/>
+              </a:rPr>
+              <a:t>源码提示词</a:t>
+            </a:r>
+          </a:p>
+        </p:txBody>
+      </p:sp>
+      <p:sp>
+        <p:nvSpPr>
+          <p:cNvPr id="11" name="Rounded Rectangle 10"/>
+          <p:cNvSpPr/>
+          <p:nvPr/>
+        </p:nvSpPr>
+        <p:spPr>
+          <a:xfrm>
+            <a:off x="7150608" y="4059936"/>
+            <a:ext cx="4389120" cy="1938528"/>
           </a:xfrm>
           <a:prstGeom prst="roundRect">
             <a:avLst/>
@@ -25915,13 +26570,13 @@
       </p:sp>
       <p:sp>
         <p:nvSpPr>
-          <p:cNvPr id="10" name="Rectangle 9"/>
-          <p:cNvSpPr/>
-          <p:nvPr/>
-        </p:nvSpPr>
-        <p:spPr>
-          <a:xfrm>
-            <a:off x="7150608" y="2359152"/>
+          <p:cNvPr id="12" name="Rectangle 11"/>
+          <p:cNvSpPr/>
+          <p:nvPr/>
+        </p:nvSpPr>
+        <p:spPr>
+          <a:xfrm>
+            <a:off x="7150608" y="4059936"/>
             <a:ext cx="4389120" cy="310896"/>
           </a:xfrm>
           <a:prstGeom prst="rect">
@@ -25960,21 +26615,21 @@
                 </a:solidFill>
                 <a:latin typeface="Arial"/>
               </a:rPr>
-              <a:t>实践含义</a:t>
-            </a:r>
-          </a:p>
-        </p:txBody>
-      </p:sp>
-      <p:sp>
-        <p:nvSpPr>
-          <p:cNvPr id="11" name="TextBox 10"/>
+              <a:t>这段代码说明什么</a:t>
+            </a:r>
+          </a:p>
+        </p:txBody>
+      </p:sp>
+      <p:sp>
+        <p:nvSpPr>
+          <p:cNvPr id="13" name="TextBox 12"/>
           <p:cNvSpPr txBox="1"/>
           <p:nvPr/>
         </p:nvSpPr>
         <p:spPr>
           <a:xfrm>
-            <a:off x="7296912" y="2706624"/>
-            <a:ext cx="4078224" cy="3200400"/>
+            <a:off x="7223760" y="4407408"/>
+            <a:ext cx="4242816" cy="1517904"/>
           </a:xfrm>
           <a:prstGeom prst="rect">
             <a:avLst/>
@@ -25993,7 +26648,7 @@
               </a:spcAft>
             </a:pPr>
             <a:r>
-              <a:rPr sz="1700" b="0">
+              <a:rPr sz="1250" b="0">
                 <a:solidFill>
                   <a:srgbClr val="DCE4F2"/>
                 </a:solidFill>
@@ -26006,7 +26661,7 @@
       </p:sp>
       <p:sp>
         <p:nvSpPr>
-          <p:cNvPr id="12" name="TextBox 11"/>
+          <p:cNvPr id="14" name="TextBox 13"/>
           <p:cNvSpPr txBox="1"/>
           <p:nvPr/>
         </p:nvSpPr>
@@ -30412,7 +31067,115 @@
         <p:spPr>
           <a:xfrm>
             <a:off x="7150608" y="2359152"/>
-            <a:ext cx="4389120" cy="3639312"/>
+            <a:ext cx="4389120" cy="1554480"/>
+          </a:xfrm>
+          <a:prstGeom prst="roundRect">
+            <a:avLst/>
+          </a:prstGeom>
+          <a:solidFill>
+            <a:srgbClr val="040C1C"/>
+          </a:solidFill>
+          <a:ln>
+            <a:solidFill>
+              <a:srgbClr val="38BDF8"/>
+            </a:solidFill>
+          </a:ln>
+        </p:spPr>
+        <p:style>
+          <a:lnRef idx="1">
+            <a:schemeClr val="accent1"/>
+          </a:lnRef>
+          <a:fillRef idx="3">
+            <a:schemeClr val="accent1"/>
+          </a:fillRef>
+          <a:effectRef idx="2">
+            <a:schemeClr val="accent1"/>
+          </a:effectRef>
+          <a:fontRef idx="minor">
+            <a:schemeClr val="lt1"/>
+          </a:fontRef>
+        </p:style>
+        <p:txBody>
+          <a:bodyPr rtlCol="0" anchor="t" wrap="square" tIns="190500" bIns="76200" lIns="127000" rIns="127000"/>
+          <a:lstStyle/>
+          <a:p>
+            <a:pPr algn="ctr"/>
+            <a:r>
+              <a:rPr sz="1150" b="0">
+                <a:solidFill>
+                  <a:srgbClr val="BBF7FF"/>
+                </a:solidFill>
+                <a:latin typeface="Courier New"/>
+              </a:rPr>
+              <a:t>Start by quickly scanning a few key files.
+Update the plan.
+Ask the user only about information the code cannot answer.</a:t>
+            </a:r>
+          </a:p>
+        </p:txBody>
+      </p:sp>
+      <p:sp>
+        <p:nvSpPr>
+          <p:cNvPr id="10" name="Rectangle 9"/>
+          <p:cNvSpPr/>
+          <p:nvPr/>
+        </p:nvSpPr>
+        <p:spPr>
+          <a:xfrm>
+            <a:off x="7150608" y="2359152"/>
+            <a:ext cx="4389120" cy="256032"/>
+          </a:xfrm>
+          <a:prstGeom prst="rect">
+            <a:avLst/>
+          </a:prstGeom>
+          <a:solidFill>
+            <a:srgbClr val="0C1B38"/>
+          </a:solidFill>
+          <a:ln>
+            <a:noFill/>
+          </a:ln>
+        </p:spPr>
+        <p:style>
+          <a:lnRef idx="1">
+            <a:schemeClr val="accent1"/>
+          </a:lnRef>
+          <a:fillRef idx="3">
+            <a:schemeClr val="accent1"/>
+          </a:fillRef>
+          <a:effectRef idx="2">
+            <a:schemeClr val="accent1"/>
+          </a:effectRef>
+          <a:fontRef idx="minor">
+            <a:schemeClr val="lt1"/>
+          </a:fontRef>
+        </p:style>
+        <p:txBody>
+          <a:bodyPr rtlCol="0" anchor="t" wrap="square" tIns="12700" bIns="12700" lIns="76200" rIns="76200"/>
+          <a:lstStyle/>
+          <a:p>
+            <a:pPr algn="ctr"/>
+            <a:r>
+              <a:rPr sz="1000" b="1">
+                <a:solidFill>
+                  <a:srgbClr val="38BDF8"/>
+                </a:solidFill>
+                <a:latin typeface="Courier New"/>
+              </a:rPr>
+              <a:t>源码提示词</a:t>
+            </a:r>
+          </a:p>
+        </p:txBody>
+      </p:sp>
+      <p:sp>
+        <p:nvSpPr>
+          <p:cNvPr id="11" name="Rounded Rectangle 10"/>
+          <p:cNvSpPr/>
+          <p:nvPr/>
+        </p:nvSpPr>
+        <p:spPr>
+          <a:xfrm>
+            <a:off x="7150608" y="4059936"/>
+            <a:ext cx="4389120" cy="1938528"/>
           </a:xfrm>
           <a:prstGeom prst="roundRect">
             <a:avLst/>
@@ -30450,13 +31213,13 @@
       </p:sp>
       <p:sp>
         <p:nvSpPr>
-          <p:cNvPr id="10" name="Rectangle 9"/>
-          <p:cNvSpPr/>
-          <p:nvPr/>
-        </p:nvSpPr>
-        <p:spPr>
-          <a:xfrm>
-            <a:off x="7150608" y="2359152"/>
+          <p:cNvPr id="12" name="Rectangle 11"/>
+          <p:cNvSpPr/>
+          <p:nvPr/>
+        </p:nvSpPr>
+        <p:spPr>
+          <a:xfrm>
+            <a:off x="7150608" y="4059936"/>
             <a:ext cx="4389120" cy="310896"/>
           </a:xfrm>
           <a:prstGeom prst="rect">
@@ -30495,21 +31258,21 @@
                 </a:solidFill>
                 <a:latin typeface="Arial"/>
               </a:rPr>
-              <a:t>实践含义</a:t>
-            </a:r>
-          </a:p>
-        </p:txBody>
-      </p:sp>
-      <p:sp>
-        <p:nvSpPr>
-          <p:cNvPr id="11" name="TextBox 10"/>
+              <a:t>这段代码说明什么</a:t>
+            </a:r>
+          </a:p>
+        </p:txBody>
+      </p:sp>
+      <p:sp>
+        <p:nvSpPr>
+          <p:cNvPr id="13" name="TextBox 12"/>
           <p:cNvSpPr txBox="1"/>
           <p:nvPr/>
         </p:nvSpPr>
         <p:spPr>
           <a:xfrm>
-            <a:off x="7296912" y="2706624"/>
-            <a:ext cx="4078224" cy="3200400"/>
+            <a:off x="7223760" y="4407408"/>
+            <a:ext cx="4242816" cy="1517904"/>
           </a:xfrm>
           <a:prstGeom prst="rect">
             <a:avLst/>
@@ -30528,7 +31291,7 @@
               </a:spcAft>
             </a:pPr>
             <a:r>
-              <a:rPr sz="1700" b="0">
+              <a:rPr sz="1250" b="0">
                 <a:solidFill>
                   <a:srgbClr val="DCE4F2"/>
                 </a:solidFill>
@@ -30541,7 +31304,7 @@
       </p:sp>
       <p:sp>
         <p:nvSpPr>
-          <p:cNvPr id="12" name="TextBox 11"/>
+          <p:cNvPr id="14" name="TextBox 13"/>
           <p:cNvSpPr txBox="1"/>
           <p:nvPr/>
         </p:nvSpPr>
@@ -31526,7 +32289,113 @@
         <p:spPr>
           <a:xfrm>
             <a:off x="7150608" y="2359152"/>
-            <a:ext cx="4389120" cy="3639312"/>
+            <a:ext cx="4389120" cy="1554480"/>
+          </a:xfrm>
+          <a:prstGeom prst="roundRect">
+            <a:avLst/>
+          </a:prstGeom>
+          <a:solidFill>
+            <a:srgbClr val="040C1C"/>
+          </a:solidFill>
+          <a:ln>
+            <a:solidFill>
+              <a:srgbClr val="38BDF8"/>
+            </a:solidFill>
+          </a:ln>
+        </p:spPr>
+        <p:style>
+          <a:lnRef idx="1">
+            <a:schemeClr val="accent1"/>
+          </a:lnRef>
+          <a:fillRef idx="3">
+            <a:schemeClr val="accent1"/>
+          </a:fillRef>
+          <a:effectRef idx="2">
+            <a:schemeClr val="accent1"/>
+          </a:effectRef>
+          <a:fontRef idx="minor">
+            <a:schemeClr val="lt1"/>
+          </a:fontRef>
+        </p:style>
+        <p:txBody>
+          <a:bodyPr rtlCol="0" anchor="t" wrap="square" tIns="190500" bIns="76200" lIns="127000" rIns="127000"/>
+          <a:lstStyle/>
+          <a:p>
+            <a:pPr algn="ctr"/>
+            <a:r>
+              <a:rPr sz="1150" b="0">
+                <a:solidFill>
+                  <a:srgbClr val="BBF7FF"/>
+                </a:solidFill>
+                <a:latin typeface="Courier New"/>
+              </a:rPr>
+              <a:t>If there are no dependencies between them, make all independent tool calls in parallel.</a:t>
+            </a:r>
+          </a:p>
+        </p:txBody>
+      </p:sp>
+      <p:sp>
+        <p:nvSpPr>
+          <p:cNvPr id="10" name="Rectangle 9"/>
+          <p:cNvSpPr/>
+          <p:nvPr/>
+        </p:nvSpPr>
+        <p:spPr>
+          <a:xfrm>
+            <a:off x="7150608" y="2359152"/>
+            <a:ext cx="4389120" cy="256032"/>
+          </a:xfrm>
+          <a:prstGeom prst="rect">
+            <a:avLst/>
+          </a:prstGeom>
+          <a:solidFill>
+            <a:srgbClr val="0C1B38"/>
+          </a:solidFill>
+          <a:ln>
+            <a:noFill/>
+          </a:ln>
+        </p:spPr>
+        <p:style>
+          <a:lnRef idx="1">
+            <a:schemeClr val="accent1"/>
+          </a:lnRef>
+          <a:fillRef idx="3">
+            <a:schemeClr val="accent1"/>
+          </a:fillRef>
+          <a:effectRef idx="2">
+            <a:schemeClr val="accent1"/>
+          </a:effectRef>
+          <a:fontRef idx="minor">
+            <a:schemeClr val="lt1"/>
+          </a:fontRef>
+        </p:style>
+        <p:txBody>
+          <a:bodyPr rtlCol="0" anchor="t" wrap="square" tIns="12700" bIns="12700" lIns="76200" rIns="76200"/>
+          <a:lstStyle/>
+          <a:p>
+            <a:pPr algn="ctr"/>
+            <a:r>
+              <a:rPr sz="1000" b="1">
+                <a:solidFill>
+                  <a:srgbClr val="38BDF8"/>
+                </a:solidFill>
+                <a:latin typeface="Courier New"/>
+              </a:rPr>
+              <a:t>源码提示词</a:t>
+            </a:r>
+          </a:p>
+        </p:txBody>
+      </p:sp>
+      <p:sp>
+        <p:nvSpPr>
+          <p:cNvPr id="11" name="Rounded Rectangle 10"/>
+          <p:cNvSpPr/>
+          <p:nvPr/>
+        </p:nvSpPr>
+        <p:spPr>
+          <a:xfrm>
+            <a:off x="7150608" y="4059936"/>
+            <a:ext cx="4389120" cy="1938528"/>
           </a:xfrm>
           <a:prstGeom prst="roundRect">
             <a:avLst/>
@@ -31564,13 +32433,13 @@
       </p:sp>
       <p:sp>
         <p:nvSpPr>
-          <p:cNvPr id="10" name="Rectangle 9"/>
-          <p:cNvSpPr/>
-          <p:nvPr/>
-        </p:nvSpPr>
-        <p:spPr>
-          <a:xfrm>
-            <a:off x="7150608" y="2359152"/>
+          <p:cNvPr id="12" name="Rectangle 11"/>
+          <p:cNvSpPr/>
+          <p:nvPr/>
+        </p:nvSpPr>
+        <p:spPr>
+          <a:xfrm>
+            <a:off x="7150608" y="4059936"/>
             <a:ext cx="4389120" cy="310896"/>
           </a:xfrm>
           <a:prstGeom prst="rect">
@@ -31609,21 +32478,21 @@
                 </a:solidFill>
                 <a:latin typeface="Arial"/>
               </a:rPr>
-              <a:t>实践含义</a:t>
-            </a:r>
-          </a:p>
-        </p:txBody>
-      </p:sp>
-      <p:sp>
-        <p:nvSpPr>
-          <p:cNvPr id="11" name="TextBox 10"/>
+              <a:t>这段代码说明什么</a:t>
+            </a:r>
+          </a:p>
+        </p:txBody>
+      </p:sp>
+      <p:sp>
+        <p:nvSpPr>
+          <p:cNvPr id="13" name="TextBox 12"/>
           <p:cNvSpPr txBox="1"/>
           <p:nvPr/>
         </p:nvSpPr>
         <p:spPr>
           <a:xfrm>
-            <a:off x="7296912" y="2706624"/>
-            <a:ext cx="4078224" cy="3200400"/>
+            <a:off x="7223760" y="4407408"/>
+            <a:ext cx="4242816" cy="1517904"/>
           </a:xfrm>
           <a:prstGeom prst="rect">
             <a:avLst/>
@@ -31642,7 +32511,7 @@
               </a:spcAft>
             </a:pPr>
             <a:r>
-              <a:rPr sz="1700" b="0">
+              <a:rPr sz="1250" b="0">
                 <a:solidFill>
                   <a:srgbClr val="DCE4F2"/>
                 </a:solidFill>
@@ -31655,7 +32524,7 @@
       </p:sp>
       <p:sp>
         <p:nvSpPr>
-          <p:cNvPr id="12" name="TextBox 11"/>
+          <p:cNvPr id="14" name="TextBox 13"/>
           <p:cNvSpPr txBox="1"/>
           <p:nvPr/>
         </p:nvSpPr>
@@ -32083,7 +32952,118 @@
         <p:spPr>
           <a:xfrm>
             <a:off x="7150608" y="2359152"/>
-            <a:ext cx="4389120" cy="3639312"/>
+            <a:ext cx="4389120" cy="1554480"/>
+          </a:xfrm>
+          <a:prstGeom prst="roundRect">
+            <a:avLst/>
+          </a:prstGeom>
+          <a:solidFill>
+            <a:srgbClr val="040C1C"/>
+          </a:solidFill>
+          <a:ln>
+            <a:solidFill>
+              <a:srgbClr val="38BDF8"/>
+            </a:solidFill>
+          </a:ln>
+        </p:spPr>
+        <p:style>
+          <a:lnRef idx="1">
+            <a:schemeClr val="accent1"/>
+          </a:lnRef>
+          <a:fillRef idx="3">
+            <a:schemeClr val="accent1"/>
+          </a:fillRef>
+          <a:effectRef idx="2">
+            <a:schemeClr val="accent1"/>
+          </a:effectRef>
+          <a:fontRef idx="minor">
+            <a:schemeClr val="lt1"/>
+          </a:fontRef>
+        </p:style>
+        <p:txBody>
+          <a:bodyPr rtlCol="0" anchor="t" wrap="square" tIns="190500" bIns="76200" lIns="127000" rIns="127000"/>
+          <a:lstStyle/>
+          <a:p>
+            <a:pPr algn="ctr"/>
+            <a:r>
+              <a:rPr sz="1150" b="0">
+                <a:solidFill>
+                  <a:srgbClr val="BBF7FF"/>
+                </a:solidFill>
+                <a:latin typeface="Courier New"/>
+              </a:rPr>
+              <a:t>type State = {
+  messages: Message[]
+  toolUseContext: ToolUseContext
+  turnCount: number
+  transition: Continue | undefined
+}</a:t>
+            </a:r>
+          </a:p>
+        </p:txBody>
+      </p:sp>
+      <p:sp>
+        <p:nvSpPr>
+          <p:cNvPr id="10" name="Rectangle 9"/>
+          <p:cNvSpPr/>
+          <p:nvPr/>
+        </p:nvSpPr>
+        <p:spPr>
+          <a:xfrm>
+            <a:off x="7150608" y="2359152"/>
+            <a:ext cx="4389120" cy="256032"/>
+          </a:xfrm>
+          <a:prstGeom prst="rect">
+            <a:avLst/>
+          </a:prstGeom>
+          <a:solidFill>
+            <a:srgbClr val="0C1B38"/>
+          </a:solidFill>
+          <a:ln>
+            <a:noFill/>
+          </a:ln>
+        </p:spPr>
+        <p:style>
+          <a:lnRef idx="1">
+            <a:schemeClr val="accent1"/>
+          </a:lnRef>
+          <a:fillRef idx="3">
+            <a:schemeClr val="accent1"/>
+          </a:fillRef>
+          <a:effectRef idx="2">
+            <a:schemeClr val="accent1"/>
+          </a:effectRef>
+          <a:fontRef idx="minor">
+            <a:schemeClr val="lt1"/>
+          </a:fontRef>
+        </p:style>
+        <p:txBody>
+          <a:bodyPr rtlCol="0" anchor="t" wrap="square" tIns="12700" bIns="12700" lIns="76200" rIns="76200"/>
+          <a:lstStyle/>
+          <a:p>
+            <a:pPr algn="ctr"/>
+            <a:r>
+              <a:rPr sz="1000" b="1">
+                <a:solidFill>
+                  <a:srgbClr val="38BDF8"/>
+                </a:solidFill>
+                <a:latin typeface="Courier New"/>
+              </a:rPr>
+              <a:t>源码代码</a:t>
+            </a:r>
+          </a:p>
+        </p:txBody>
+      </p:sp>
+      <p:sp>
+        <p:nvSpPr>
+          <p:cNvPr id="11" name="Rounded Rectangle 10"/>
+          <p:cNvSpPr/>
+          <p:nvPr/>
+        </p:nvSpPr>
+        <p:spPr>
+          <a:xfrm>
+            <a:off x="7150608" y="4059936"/>
+            <a:ext cx="4389120" cy="1938528"/>
           </a:xfrm>
           <a:prstGeom prst="roundRect">
             <a:avLst/>
@@ -32121,13 +33101,13 @@
       </p:sp>
       <p:sp>
         <p:nvSpPr>
-          <p:cNvPr id="10" name="Rectangle 9"/>
-          <p:cNvSpPr/>
-          <p:nvPr/>
-        </p:nvSpPr>
-        <p:spPr>
-          <a:xfrm>
-            <a:off x="7150608" y="2359152"/>
+          <p:cNvPr id="12" name="Rectangle 11"/>
+          <p:cNvSpPr/>
+          <p:nvPr/>
+        </p:nvSpPr>
+        <p:spPr>
+          <a:xfrm>
+            <a:off x="7150608" y="4059936"/>
             <a:ext cx="4389120" cy="310896"/>
           </a:xfrm>
           <a:prstGeom prst="rect">
@@ -32166,21 +33146,21 @@
                 </a:solidFill>
                 <a:latin typeface="Arial"/>
               </a:rPr>
-              <a:t>实践含义</a:t>
-            </a:r>
-          </a:p>
-        </p:txBody>
-      </p:sp>
-      <p:sp>
-        <p:nvSpPr>
-          <p:cNvPr id="11" name="TextBox 10"/>
+              <a:t>这段代码说明什么</a:t>
+            </a:r>
+          </a:p>
+        </p:txBody>
+      </p:sp>
+      <p:sp>
+        <p:nvSpPr>
+          <p:cNvPr id="13" name="TextBox 12"/>
           <p:cNvSpPr txBox="1"/>
           <p:nvPr/>
         </p:nvSpPr>
         <p:spPr>
           <a:xfrm>
-            <a:off x="7296912" y="2706624"/>
-            <a:ext cx="4078224" cy="3200400"/>
+            <a:off x="7223760" y="4407408"/>
+            <a:ext cx="4242816" cy="1517904"/>
           </a:xfrm>
           <a:prstGeom prst="rect">
             <a:avLst/>
@@ -32199,7 +33179,7 @@
               </a:spcAft>
             </a:pPr>
             <a:r>
-              <a:rPr sz="1700" b="0">
+              <a:rPr sz="1250" b="0">
                 <a:solidFill>
                   <a:srgbClr val="DCE4F2"/>
                 </a:solidFill>
@@ -32212,7 +33192,7 @@
       </p:sp>
       <p:sp>
         <p:nvSpPr>
-          <p:cNvPr id="12" name="TextBox 11"/>
+          <p:cNvPr id="14" name="TextBox 13"/>
           <p:cNvSpPr txBox="1"/>
           <p:nvPr/>
         </p:nvSpPr>
@@ -32640,7 +33620,113 @@
         <p:spPr>
           <a:xfrm>
             <a:off x="7150608" y="2359152"/>
-            <a:ext cx="4389120" cy="3639312"/>
+            <a:ext cx="4389120" cy="1554480"/>
+          </a:xfrm>
+          <a:prstGeom prst="roundRect">
+            <a:avLst/>
+          </a:prstGeom>
+          <a:solidFill>
+            <a:srgbClr val="040C1C"/>
+          </a:solidFill>
+          <a:ln>
+            <a:solidFill>
+              <a:srgbClr val="38BDF8"/>
+            </a:solidFill>
+          </a:ln>
+        </p:spPr>
+        <p:style>
+          <a:lnRef idx="1">
+            <a:schemeClr val="accent1"/>
+          </a:lnRef>
+          <a:fillRef idx="3">
+            <a:schemeClr val="accent1"/>
+          </a:fillRef>
+          <a:effectRef idx="2">
+            <a:schemeClr val="accent1"/>
+          </a:effectRef>
+          <a:fontRef idx="minor">
+            <a:schemeClr val="lt1"/>
+          </a:fontRef>
+        </p:style>
+        <p:txBody>
+          <a:bodyPr rtlCol="0" anchor="t" wrap="square" tIns="190500" bIns="76200" lIns="127000" rIns="127000"/>
+          <a:lstStyle/>
+          <a:p>
+            <a:pPr algn="ctr"/>
+            <a:r>
+              <a:rPr sz="1150" b="0">
+                <a:solidFill>
+                  <a:srgbClr val="BBF7FF"/>
+                </a:solidFill>
+                <a:latin typeface="Courier New"/>
+              </a:rPr>
+              <a:t>Don't add features, refactor code, or make improvements beyond what was explicitly asked.</a:t>
+            </a:r>
+          </a:p>
+        </p:txBody>
+      </p:sp>
+      <p:sp>
+        <p:nvSpPr>
+          <p:cNvPr id="10" name="Rectangle 9"/>
+          <p:cNvSpPr/>
+          <p:nvPr/>
+        </p:nvSpPr>
+        <p:spPr>
+          <a:xfrm>
+            <a:off x="7150608" y="2359152"/>
+            <a:ext cx="4389120" cy="256032"/>
+          </a:xfrm>
+          <a:prstGeom prst="rect">
+            <a:avLst/>
+          </a:prstGeom>
+          <a:solidFill>
+            <a:srgbClr val="0C1B38"/>
+          </a:solidFill>
+          <a:ln>
+            <a:noFill/>
+          </a:ln>
+        </p:spPr>
+        <p:style>
+          <a:lnRef idx="1">
+            <a:schemeClr val="accent1"/>
+          </a:lnRef>
+          <a:fillRef idx="3">
+            <a:schemeClr val="accent1"/>
+          </a:fillRef>
+          <a:effectRef idx="2">
+            <a:schemeClr val="accent1"/>
+          </a:effectRef>
+          <a:fontRef idx="minor">
+            <a:schemeClr val="lt1"/>
+          </a:fontRef>
+        </p:style>
+        <p:txBody>
+          <a:bodyPr rtlCol="0" anchor="t" wrap="square" tIns="12700" bIns="12700" lIns="76200" rIns="76200"/>
+          <a:lstStyle/>
+          <a:p>
+            <a:pPr algn="ctr"/>
+            <a:r>
+              <a:rPr sz="1000" b="1">
+                <a:solidFill>
+                  <a:srgbClr val="38BDF8"/>
+                </a:solidFill>
+                <a:latin typeface="Courier New"/>
+              </a:rPr>
+              <a:t>源码提示词</a:t>
+            </a:r>
+          </a:p>
+        </p:txBody>
+      </p:sp>
+      <p:sp>
+        <p:nvSpPr>
+          <p:cNvPr id="11" name="Rounded Rectangle 10"/>
+          <p:cNvSpPr/>
+          <p:nvPr/>
+        </p:nvSpPr>
+        <p:spPr>
+          <a:xfrm>
+            <a:off x="7150608" y="4059936"/>
+            <a:ext cx="4389120" cy="1938528"/>
           </a:xfrm>
           <a:prstGeom prst="roundRect">
             <a:avLst/>
@@ -32678,13 +33764,13 @@
       </p:sp>
       <p:sp>
         <p:nvSpPr>
-          <p:cNvPr id="10" name="Rectangle 9"/>
-          <p:cNvSpPr/>
-          <p:nvPr/>
-        </p:nvSpPr>
-        <p:spPr>
-          <a:xfrm>
-            <a:off x="7150608" y="2359152"/>
+          <p:cNvPr id="12" name="Rectangle 11"/>
+          <p:cNvSpPr/>
+          <p:nvPr/>
+        </p:nvSpPr>
+        <p:spPr>
+          <a:xfrm>
+            <a:off x="7150608" y="4059936"/>
             <a:ext cx="4389120" cy="310896"/>
           </a:xfrm>
           <a:prstGeom prst="rect">
@@ -32723,21 +33809,21 @@
                 </a:solidFill>
                 <a:latin typeface="Arial"/>
               </a:rPr>
-              <a:t>实践含义</a:t>
-            </a:r>
-          </a:p>
-        </p:txBody>
-      </p:sp>
-      <p:sp>
-        <p:nvSpPr>
-          <p:cNvPr id="11" name="TextBox 10"/>
+              <a:t>这段代码说明什么</a:t>
+            </a:r>
+          </a:p>
+        </p:txBody>
+      </p:sp>
+      <p:sp>
+        <p:nvSpPr>
+          <p:cNvPr id="13" name="TextBox 12"/>
           <p:cNvSpPr txBox="1"/>
           <p:nvPr/>
         </p:nvSpPr>
         <p:spPr>
           <a:xfrm>
-            <a:off x="7296912" y="2706624"/>
-            <a:ext cx="4078224" cy="3200400"/>
+            <a:off x="7223760" y="4407408"/>
+            <a:ext cx="4242816" cy="1517904"/>
           </a:xfrm>
           <a:prstGeom prst="rect">
             <a:avLst/>
@@ -32756,7 +33842,7 @@
               </a:spcAft>
             </a:pPr>
             <a:r>
-              <a:rPr sz="1700" b="0">
+              <a:rPr sz="1250" b="0">
                 <a:solidFill>
                   <a:srgbClr val="DCE4F2"/>
                 </a:solidFill>
@@ -32769,7 +33855,7 @@
       </p:sp>
       <p:sp>
         <p:nvSpPr>
-          <p:cNvPr id="12" name="TextBox 11"/>
+          <p:cNvPr id="14" name="TextBox 13"/>
           <p:cNvSpPr txBox="1"/>
           <p:nvPr/>
         </p:nvSpPr>
@@ -33197,7 +34283,114 @@
         <p:spPr>
           <a:xfrm>
             <a:off x="7150608" y="2359152"/>
-            <a:ext cx="4389120" cy="3639312"/>
+            <a:ext cx="4389120" cy="1554480"/>
+          </a:xfrm>
+          <a:prstGeom prst="roundRect">
+            <a:avLst/>
+          </a:prstGeom>
+          <a:solidFill>
+            <a:srgbClr val="040C1C"/>
+          </a:solidFill>
+          <a:ln>
+            <a:solidFill>
+              <a:srgbClr val="38BDF8"/>
+            </a:solidFill>
+          </a:ln>
+        </p:spPr>
+        <p:style>
+          <a:lnRef idx="1">
+            <a:schemeClr val="accent1"/>
+          </a:lnRef>
+          <a:fillRef idx="3">
+            <a:schemeClr val="accent1"/>
+          </a:fillRef>
+          <a:effectRef idx="2">
+            <a:schemeClr val="accent1"/>
+          </a:effectRef>
+          <a:fontRef idx="minor">
+            <a:schemeClr val="lt1"/>
+          </a:fontRef>
+        </p:style>
+        <p:txBody>
+          <a:bodyPr rtlCol="0" anchor="t" wrap="square" tIns="190500" bIns="76200" lIns="127000" rIns="127000"/>
+          <a:lstStyle/>
+          <a:p>
+            <a:pPr algn="ctr"/>
+            <a:r>
+              <a:rPr sz="1150" b="0">
+                <a:solidFill>
+                  <a:srgbClr val="BBF7FF"/>
+                </a:solidFill>
+                <a:latin typeface="Courier New"/>
+              </a:rPr>
+              <a:t>You are running as an agent in a team.
+Use the SendMessage tool.</a:t>
+            </a:r>
+          </a:p>
+        </p:txBody>
+      </p:sp>
+      <p:sp>
+        <p:nvSpPr>
+          <p:cNvPr id="10" name="Rectangle 9"/>
+          <p:cNvSpPr/>
+          <p:nvPr/>
+        </p:nvSpPr>
+        <p:spPr>
+          <a:xfrm>
+            <a:off x="7150608" y="2359152"/>
+            <a:ext cx="4389120" cy="256032"/>
+          </a:xfrm>
+          <a:prstGeom prst="rect">
+            <a:avLst/>
+          </a:prstGeom>
+          <a:solidFill>
+            <a:srgbClr val="0C1B38"/>
+          </a:solidFill>
+          <a:ln>
+            <a:noFill/>
+          </a:ln>
+        </p:spPr>
+        <p:style>
+          <a:lnRef idx="1">
+            <a:schemeClr val="accent1"/>
+          </a:lnRef>
+          <a:fillRef idx="3">
+            <a:schemeClr val="accent1"/>
+          </a:fillRef>
+          <a:effectRef idx="2">
+            <a:schemeClr val="accent1"/>
+          </a:effectRef>
+          <a:fontRef idx="minor">
+            <a:schemeClr val="lt1"/>
+          </a:fontRef>
+        </p:style>
+        <p:txBody>
+          <a:bodyPr rtlCol="0" anchor="t" wrap="square" tIns="12700" bIns="12700" lIns="76200" rIns="76200"/>
+          <a:lstStyle/>
+          <a:p>
+            <a:pPr algn="ctr"/>
+            <a:r>
+              <a:rPr sz="1000" b="1">
+                <a:solidFill>
+                  <a:srgbClr val="38BDF8"/>
+                </a:solidFill>
+                <a:latin typeface="Courier New"/>
+              </a:rPr>
+              <a:t>源码提示词</a:t>
+            </a:r>
+          </a:p>
+        </p:txBody>
+      </p:sp>
+      <p:sp>
+        <p:nvSpPr>
+          <p:cNvPr id="11" name="Rounded Rectangle 10"/>
+          <p:cNvSpPr/>
+          <p:nvPr/>
+        </p:nvSpPr>
+        <p:spPr>
+          <a:xfrm>
+            <a:off x="7150608" y="4059936"/>
+            <a:ext cx="4389120" cy="1938528"/>
           </a:xfrm>
           <a:prstGeom prst="roundRect">
             <a:avLst/>
@@ -33235,13 +34428,13 @@
       </p:sp>
       <p:sp>
         <p:nvSpPr>
-          <p:cNvPr id="10" name="Rectangle 9"/>
-          <p:cNvSpPr/>
-          <p:nvPr/>
-        </p:nvSpPr>
-        <p:spPr>
-          <a:xfrm>
-            <a:off x="7150608" y="2359152"/>
+          <p:cNvPr id="12" name="Rectangle 11"/>
+          <p:cNvSpPr/>
+          <p:nvPr/>
+        </p:nvSpPr>
+        <p:spPr>
+          <a:xfrm>
+            <a:off x="7150608" y="4059936"/>
             <a:ext cx="4389120" cy="310896"/>
           </a:xfrm>
           <a:prstGeom prst="rect">
@@ -33280,21 +34473,21 @@
                 </a:solidFill>
                 <a:latin typeface="Arial"/>
               </a:rPr>
-              <a:t>实践含义</a:t>
-            </a:r>
-          </a:p>
-        </p:txBody>
-      </p:sp>
-      <p:sp>
-        <p:nvSpPr>
-          <p:cNvPr id="11" name="TextBox 10"/>
+              <a:t>这段代码说明什么</a:t>
+            </a:r>
+          </a:p>
+        </p:txBody>
+      </p:sp>
+      <p:sp>
+        <p:nvSpPr>
+          <p:cNvPr id="13" name="TextBox 12"/>
           <p:cNvSpPr txBox="1"/>
           <p:nvPr/>
         </p:nvSpPr>
         <p:spPr>
           <a:xfrm>
-            <a:off x="7296912" y="2706624"/>
-            <a:ext cx="4078224" cy="3200400"/>
+            <a:off x="7223760" y="4407408"/>
+            <a:ext cx="4242816" cy="1517904"/>
           </a:xfrm>
           <a:prstGeom prst="rect">
             <a:avLst/>
@@ -33313,7 +34506,7 @@
               </a:spcAft>
             </a:pPr>
             <a:r>
-              <a:rPr sz="1700" b="0">
+              <a:rPr sz="1250" b="0">
                 <a:solidFill>
                   <a:srgbClr val="DCE4F2"/>
                 </a:solidFill>
@@ -33326,7 +34519,7 @@
       </p:sp>
       <p:sp>
         <p:nvSpPr>
-          <p:cNvPr id="12" name="TextBox 11"/>
+          <p:cNvPr id="14" name="TextBox 13"/>
           <p:cNvSpPr txBox="1"/>
           <p:nvPr/>
         </p:nvSpPr>

</xml_diff>